<commit_message>
Ground charts in real ledger data; separate actual from projected
Add real 15-month actual income vs expense chart from the books; fix empty cost chart (now real ledger heads: Salary 72L, Rent 14.65L, etc, FY27 to date); break-even charts show actual (solid, Apr-Jun) vs projected (dashed) with divider; label FY26 actual vs FY27+ projected throughout. Web page and PPT. PPT validated.
</commit_message>
<xml_diff>
--- a/board/AOP_board_presentation.pptx
+++ b/board/AOP_board_presentation.pptx
@@ -123,6 +123,791 @@
   <c:date1904 val="0"/>
   <c:roundedCorners val="1"/>
   <c:chart>
+    <c:autoTitleDeleted val="1"/>
+    <c:plotArea>
+      <c:layout/>
+      <c:areaChart>
+        <c:varyColors val="0"/>
+        <c:ser>
+          <c:idx val="0"/>
+          <c:order val="0"/>
+          <c:tx>
+            <c:strRef>
+              <c:f>Sheet1!$B$1</c:f>
+              <c:strCache>
+                <c:ptCount val="1"/>
+                <c:pt idx="0">
+                  <c:v>Income (FD + ratings)</c:v>
+                </c:pt>
+              </c:strCache>
+            </c:strRef>
+          </c:tx>
+          <c:spPr>
+            <a:solidFill>
+              <a:srgbClr val="0F766E">
+                <a:alpha val="35000"/>
+              </a:srgbClr>
+            </a:solidFill>
+            <a:effectLst/>
+          </c:spPr>
+          <c:invertIfNegative val="0"/>
+          <c:dLbls>
+            <c:numFmt formatCode="#,##0" sourceLinked="0"/>
+            <c:txPr>
+              <a:bodyPr/>
+              <a:lstStyle/>
+              <a:p>
+                <a:pPr>
+                  <a:defRPr b="0" i="0" strike="noStrike" sz="1200" u="none">
+                    <a:solidFill>
+                      <a:srgbClr val="000000"/>
+                    </a:solidFill>
+                    <a:latin typeface="Arial"/>
+                  </a:defRPr>
+                </a:pPr>
+              </a:p>
+            </c:txPr>
+            <c:showLegendKey val="0"/>
+            <c:showVal val="0"/>
+            <c:showCatName val="0"/>
+            <c:showSerName val="0"/>
+            <c:showPercent val="0"/>
+            <c:showBubbleSize val="0"/>
+            <c:showLeaderLines val="0"/>
+          </c:dLbls>
+          <c:cat>
+            <c:multiLvlStrRef>
+              <c:f>Sheet1!$A$2:$A$16</c:f>
+              <c:multiLvlStrCache>
+                <c:ptCount val="15"/>
+                <c:lvl>
+                  <c:pt idx="0">
+                    <c:v>Apr</c:v>
+                  </c:pt>
+                  <c:pt idx="1">
+                    <c:v>May</c:v>
+                  </c:pt>
+                  <c:pt idx="2">
+                    <c:v>Jun</c:v>
+                  </c:pt>
+                  <c:pt idx="3">
+                    <c:v>Jul</c:v>
+                  </c:pt>
+                  <c:pt idx="4">
+                    <c:v>Aug</c:v>
+                  </c:pt>
+                  <c:pt idx="5">
+                    <c:v>Sep</c:v>
+                  </c:pt>
+                  <c:pt idx="6">
+                    <c:v>Oct</c:v>
+                  </c:pt>
+                  <c:pt idx="7">
+                    <c:v>Nov</c:v>
+                  </c:pt>
+                  <c:pt idx="8">
+                    <c:v>Dec</c:v>
+                  </c:pt>
+                  <c:pt idx="9">
+                    <c:v>Jan</c:v>
+                  </c:pt>
+                  <c:pt idx="10">
+                    <c:v>Feb</c:v>
+                  </c:pt>
+                  <c:pt idx="11">
+                    <c:v>Mar</c:v>
+                  </c:pt>
+                  <c:pt idx="12">
+                    <c:v>Apr</c:v>
+                  </c:pt>
+                  <c:pt idx="13">
+                    <c:v>May</c:v>
+                  </c:pt>
+                  <c:pt idx="14">
+                    <c:v>Jun</c:v>
+                  </c:pt>
+                </c:lvl>
+              </c:multiLvlStrCache>
+            </c:multiLvlStrRef>
+          </c:cat>
+          <c:val>
+            <c:numRef>
+              <c:f>Sheet1!$B$2:$B$16</c:f>
+              <c:numCache>
+                <c:formatCode>General</c:formatCode>
+                <c:ptCount val="15"/>
+                <c:pt idx="0">
+                  <c:v>0</c:v>
+                </c:pt>
+                <c:pt idx="1">
+                  <c:v>0</c:v>
+                </c:pt>
+                <c:pt idx="2">
+                  <c:v>0.134</c:v>
+                </c:pt>
+                <c:pt idx="3">
+                  <c:v>0.015</c:v>
+                </c:pt>
+                <c:pt idx="4">
+                  <c:v>0.146</c:v>
+                </c:pt>
+                <c:pt idx="5">
+                  <c:v>0.29</c:v>
+                </c:pt>
+                <c:pt idx="6">
+                  <c:v>0.146</c:v>
+                </c:pt>
+                <c:pt idx="7">
+                  <c:v>0.145</c:v>
+                </c:pt>
+                <c:pt idx="8">
+                  <c:v>0.145</c:v>
+                </c:pt>
+                <c:pt idx="9">
+                  <c:v>0.156</c:v>
+                </c:pt>
+                <c:pt idx="10">
+                  <c:v>0.235</c:v>
+                </c:pt>
+                <c:pt idx="11">
+                  <c:v>0.149</c:v>
+                </c:pt>
+                <c:pt idx="12">
+                  <c:v>0.175</c:v>
+                </c:pt>
+                <c:pt idx="13">
+                  <c:v>0.194</c:v>
+                </c:pt>
+                <c:pt idx="14">
+                  <c:v>0.232</c:v>
+                </c:pt>
+              </c:numCache>
+            </c:numRef>
+          </c:val>
+        </c:ser>
+        <c:dLbls>
+          <c:numFmt formatCode="#,##0" sourceLinked="0"/>
+          <c:txPr>
+            <a:bodyPr/>
+            <a:lstStyle/>
+            <a:p>
+              <a:pPr>
+                <a:defRPr b="0" i="0" strike="noStrike" sz="1200" u="none">
+                  <a:solidFill>
+                    <a:srgbClr val="000000"/>
+                  </a:solidFill>
+                  <a:latin typeface="Arial"/>
+                </a:defRPr>
+              </a:pPr>
+            </a:p>
+          </c:txPr>
+          <c:showLegendKey val="0"/>
+          <c:showVal val="0"/>
+          <c:showCatName val="0"/>
+          <c:showSerName val="0"/>
+          <c:showPercent val="0"/>
+          <c:showBubbleSize val="0"/>
+          <c:showLeaderLines val="0"/>
+        </c:dLbls>
+        <c:axId val="2094734554"/>
+        <c:axId val="2094734552"/>
+        <c:axId val="2094734556"/>
+      </c:areaChart>
+      <c:lineChart>
+        <c:varyColors val="0"/>
+        <c:ser>
+          <c:idx val="1"/>
+          <c:order val="1"/>
+          <c:tx>
+            <c:strRef>
+              <c:f>Sheet1!$C$1</c:f>
+              <c:strCache>
+                <c:ptCount val="1"/>
+                <c:pt idx="0">
+                  <c:v>Expense, all in</c:v>
+                </c:pt>
+              </c:strCache>
+            </c:strRef>
+          </c:tx>
+          <c:spPr>
+            <a:solidFill>
+              <a:srgbClr val="334155"/>
+            </a:solidFill>
+            <a:ln w="25400" cap="flat">
+              <a:solidFill>
+                <a:srgbClr val="334155"/>
+              </a:solidFill>
+              <a:prstDash val="solid"/>
+              <a:round/>
+            </a:ln>
+            <a:effectLst/>
+          </c:spPr>
+          <c:invertIfNegative val="0"/>
+          <c:dLbls>
+            <c:numFmt formatCode="#,##0" sourceLinked="0"/>
+            <c:txPr>
+              <a:bodyPr/>
+              <a:lstStyle/>
+              <a:p>
+                <a:pPr>
+                  <a:defRPr b="0" i="0" strike="noStrike" sz="1200" u="none">
+                    <a:solidFill>
+                      <a:srgbClr val="000000"/>
+                    </a:solidFill>
+                    <a:latin typeface="Arial"/>
+                  </a:defRPr>
+                </a:pPr>
+              </a:p>
+            </c:txPr>
+            <c:showLegendKey val="0"/>
+            <c:showVal val="0"/>
+            <c:showCatName val="0"/>
+            <c:showSerName val="0"/>
+            <c:showPercent val="0"/>
+            <c:showBubbleSize val="0"/>
+            <c:showLeaderLines val="0"/>
+          </c:dLbls>
+          <c:marker>
+            <c:symbol val="none"/>
+            <c:size val="6"/>
+            <c:spPr>
+              <a:solidFill>
+                <a:srgbClr val="334155"/>
+              </a:solidFill>
+              <a:ln w="9525" cap="flat">
+                <a:solidFill>
+                  <a:srgbClr val="334155"/>
+                </a:solidFill>
+                <a:prstDash val="solid"/>
+                <a:round/>
+              </a:ln>
+              <a:effectLst/>
+            </c:spPr>
+          </c:marker>
+          <c:cat>
+            <c:multiLvlStrRef>
+              <c:f>Sheet1!$A$2:$A$16</c:f>
+              <c:multiLvlStrCache>
+                <c:ptCount val="15"/>
+                <c:lvl>
+                  <c:pt idx="0">
+                    <c:v>Apr</c:v>
+                  </c:pt>
+                  <c:pt idx="1">
+                    <c:v>May</c:v>
+                  </c:pt>
+                  <c:pt idx="2">
+                    <c:v>Jun</c:v>
+                  </c:pt>
+                  <c:pt idx="3">
+                    <c:v>Jul</c:v>
+                  </c:pt>
+                  <c:pt idx="4">
+                    <c:v>Aug</c:v>
+                  </c:pt>
+                  <c:pt idx="5">
+                    <c:v>Sep</c:v>
+                  </c:pt>
+                  <c:pt idx="6">
+                    <c:v>Oct</c:v>
+                  </c:pt>
+                  <c:pt idx="7">
+                    <c:v>Nov</c:v>
+                  </c:pt>
+                  <c:pt idx="8">
+                    <c:v>Dec</c:v>
+                  </c:pt>
+                  <c:pt idx="9">
+                    <c:v>Jan</c:v>
+                  </c:pt>
+                  <c:pt idx="10">
+                    <c:v>Feb</c:v>
+                  </c:pt>
+                  <c:pt idx="11">
+                    <c:v>Mar</c:v>
+                  </c:pt>
+                  <c:pt idx="12">
+                    <c:v>Apr</c:v>
+                  </c:pt>
+                  <c:pt idx="13">
+                    <c:v>May</c:v>
+                  </c:pt>
+                  <c:pt idx="14">
+                    <c:v>Jun</c:v>
+                  </c:pt>
+                </c:lvl>
+              </c:multiLvlStrCache>
+            </c:multiLvlStrRef>
+          </c:cat>
+          <c:val>
+            <c:numRef>
+              <c:f>Sheet1!$C$2:$C$16</c:f>
+              <c:numCache>
+                <c:formatCode>General</c:formatCode>
+                <c:ptCount val="15"/>
+                <c:pt idx="0">
+                  <c:v>0.036</c:v>
+                </c:pt>
+                <c:pt idx="1">
+                  <c:v>0.095</c:v>
+                </c:pt>
+                <c:pt idx="2">
+                  <c:v>0.171</c:v>
+                </c:pt>
+                <c:pt idx="3">
+                  <c:v>0.1</c:v>
+                </c:pt>
+                <c:pt idx="4">
+                  <c:v>0.14</c:v>
+                </c:pt>
+                <c:pt idx="5">
+                  <c:v>0.183</c:v>
+                </c:pt>
+                <c:pt idx="6">
+                  <c:v>0.177</c:v>
+                </c:pt>
+                <c:pt idx="7">
+                  <c:v>0.196</c:v>
+                </c:pt>
+                <c:pt idx="8">
+                  <c:v>0.334</c:v>
+                </c:pt>
+                <c:pt idx="9">
+                  <c:v>0.267</c:v>
+                </c:pt>
+                <c:pt idx="10">
+                  <c:v>0.359</c:v>
+                </c:pt>
+                <c:pt idx="11">
+                  <c:v>0.38</c:v>
+                </c:pt>
+                <c:pt idx="12">
+                  <c:v>0.364</c:v>
+                </c:pt>
+                <c:pt idx="13">
+                  <c:v>0.33</c:v>
+                </c:pt>
+                <c:pt idx="14">
+                  <c:v>0.463</c:v>
+                </c:pt>
+              </c:numCache>
+            </c:numRef>
+          </c:val>
+          <c:smooth val="0"/>
+        </c:ser>
+        <c:dLbls>
+          <c:numFmt formatCode="#,##0" sourceLinked="0"/>
+          <c:txPr>
+            <a:bodyPr/>
+            <a:lstStyle/>
+            <a:p>
+              <a:pPr>
+                <a:defRPr b="0" i="0" strike="noStrike" sz="1200" u="none">
+                  <a:solidFill>
+                    <a:srgbClr val="000000"/>
+                  </a:solidFill>
+                  <a:latin typeface="Arial"/>
+                </a:defRPr>
+              </a:pPr>
+            </a:p>
+          </c:txPr>
+          <c:showLegendKey val="0"/>
+          <c:showVal val="0"/>
+          <c:showCatName val="0"/>
+          <c:showSerName val="0"/>
+          <c:showPercent val="0"/>
+          <c:showBubbleSize val="0"/>
+          <c:showLeaderLines val="0"/>
+        </c:dLbls>
+        <c:marker val="1"/>
+        <c:axId val="2094734554"/>
+        <c:axId val="2094734552"/>
+        <c:axId val="2094734556"/>
+      </c:lineChart>
+      <c:catAx>
+        <c:axId val="2094734554"/>
+        <c:scaling>
+          <c:orientation val="minMax"/>
+        </c:scaling>
+        <c:delete val="0"/>
+        <c:axPos val="b"/>
+        <c:numFmt formatCode="General" sourceLinked="1"/>
+        <c:majorTickMark val="out"/>
+        <c:minorTickMark val="none"/>
+        <c:tickLblPos val="low"/>
+        <c:spPr>
+          <a:ln w="12700" cap="flat">
+            <a:solidFill>
+              <a:srgbClr val="888888"/>
+            </a:solidFill>
+            <a:prstDash val="solid"/>
+            <a:round/>
+          </a:ln>
+        </c:spPr>
+        <c:txPr>
+          <a:bodyPr/>
+          <a:lstStyle/>
+          <a:p>
+            <a:pPr>
+              <a:defRPr sz="800" b="0" i="0" u="none" strike="noStrike">
+                <a:solidFill>
+                  <a:srgbClr val="94A3B8"/>
+                </a:solidFill>
+                <a:latin typeface="Calibri"/>
+              </a:defRPr>
+            </a:pPr>
+            <a:endParaRPr lang="en-US"/>
+          </a:p>
+        </c:txPr>
+        <c:crossAx val="2094734552"/>
+        <c:crosses val="autoZero"/>
+        <c:auto val="1"/>
+        <c:lblAlgn val="ctr"/>
+        <c:noMultiLvlLbl val="1"/>
+      </c:catAx>
+      <c:valAx>
+        <c:axId val="2094734552"/>
+        <c:scaling>
+          <c:orientation val="minMax"/>
+          <c:max val="0.5"/>
+          <c:min val="0"/>
+        </c:scaling>
+        <c:delete val="0"/>
+        <c:axPos val="l"/>
+        <c:majorGridlines>
+          <c:spPr>
+            <a:ln w="6350" cap="flat">
+              <a:solidFill>
+                <a:srgbClr val="E2E8F0"/>
+              </a:solidFill>
+              <a:prstDash val="solid"/>
+              <a:round/>
+            </a:ln>
+          </c:spPr>
+        </c:majorGridlines>
+        <c:numFmt formatCode="General" sourceLinked="0"/>
+        <c:majorTickMark val="out"/>
+        <c:minorTickMark val="none"/>
+        <c:tickLblPos val="nextTo"/>
+        <c:spPr>
+          <a:ln w="12700" cap="flat">
+            <a:solidFill>
+              <a:srgbClr val="888888"/>
+            </a:solidFill>
+            <a:prstDash val="solid"/>
+            <a:round/>
+          </a:ln>
+        </c:spPr>
+        <c:txPr>
+          <a:bodyPr/>
+          <a:lstStyle/>
+          <a:p>
+            <a:pPr>
+              <a:defRPr sz="900" b="0" i="0" u="none" strike="noStrike">
+                <a:solidFill>
+                  <a:srgbClr val="94A3B8"/>
+                </a:solidFill>
+                <a:latin typeface="Calibri"/>
+              </a:defRPr>
+            </a:pPr>
+            <a:endParaRPr lang="en-US"/>
+          </a:p>
+        </c:txPr>
+        <c:crossAx val="2094734554"/>
+        <c:crosses val="autoZero"/>
+        <c:crossBetween val="midCat"/>
+      </c:valAx>
+      <c:spPr>
+        <a:noFill/>
+        <a:ln>
+          <a:noFill/>
+        </a:ln>
+        <a:effectLst/>
+      </c:spPr>
+    </c:plotArea>
+    <c:legend>
+      <c:legendPos val="b"/>
+      <c:overlay val="0"/>
+      <c:txPr>
+        <a:bodyPr/>
+        <a:lstStyle/>
+        <a:p>
+          <a:pPr>
+            <a:defRPr sz="1000">
+              <a:solidFill>
+                <a:srgbClr val="334155"/>
+              </a:solidFill>
+              <a:latin typeface="Calibri"/>
+              <a:cs typeface="Calibri"/>
+            </a:defRPr>
+          </a:pPr>
+          <a:endParaRPr lang="en-US"/>
+        </a:p>
+      </c:txPr>
+    </c:legend>
+    <c:plotVisOnly val="1"/>
+    <c:dispBlanksAs val="span"/>
+  </c:chart>
+  <c:spPr>
+    <a:noFill/>
+    <a:ln>
+      <a:noFill/>
+    </a:ln>
+    <a:effectLst/>
+  </c:spPr>
+  <c:externalData r:id="rId1">
+    <c:autoUpdate val="0"/>
+  </c:externalData>
+</c:chartSpace>
+</file>
+
+<file path=ppt/charts/chart10.xml><?xml version="1.0" encoding="utf-8"?>
+<c:chartSpace xmlns:c="http://schemas.openxmlformats.org/drawingml/2006/chart" xmlns:a="http://schemas.openxmlformats.org/drawingml/2006/main" xmlns:r="http://schemas.openxmlformats.org/officeDocument/2006/relationships">
+  <c:date1904 val="0"/>
+  <c:roundedCorners val="1"/>
+  <c:chart>
+    <c:autoTitleDeleted val="1"/>
+    <c:plotArea>
+      <c:layout/>
+      <c:barChart>
+        <c:barDir val="col"/>
+        <c:grouping val="clustered"/>
+        <c:varyColors val="0"/>
+        <c:ser>
+          <c:idx val="0"/>
+          <c:order val="0"/>
+          <c:tx>
+            <c:strRef>
+              <c:f>Sheet1!$B$1</c:f>
+              <c:strCache>
+                <c:ptCount val="1"/>
+                <c:pt idx="0">
+                  <c:v>ACER rating revenue</c:v>
+                </c:pt>
+              </c:strCache>
+            </c:strRef>
+          </c:tx>
+          <c:spPr>
+            <a:solidFill>
+              <a:srgbClr val="0F766E"/>
+            </a:solidFill>
+            <a:effectLst/>
+          </c:spPr>
+          <c:invertIfNegative val="0"/>
+          <c:dLbls>
+            <c:numFmt formatCode="#,##0" sourceLinked="0"/>
+            <c:txPr>
+              <a:bodyPr/>
+              <a:lstStyle/>
+              <a:p>
+                <a:pPr>
+                  <a:defRPr b="0" i="0" strike="noStrike" sz="950" u="none">
+                    <a:solidFill>
+                      <a:srgbClr val="334155"/>
+                    </a:solidFill>
+                    <a:latin typeface="Calibri"/>
+                  </a:defRPr>
+                </a:pPr>
+              </a:p>
+            </c:txPr>
+            <c:showLegendKey val="0"/>
+            <c:showVal val="1"/>
+            <c:showCatName val="0"/>
+            <c:showSerName val="0"/>
+            <c:showPercent val="0"/>
+            <c:showBubbleSize val="0"/>
+            <c:showLeaderLines val="0"/>
+          </c:dLbls>
+          <c:cat>
+            <c:multiLvlStrRef>
+              <c:f>Sheet1!$A$2:$A$6</c:f>
+              <c:multiLvlStrCache>
+                <c:ptCount val="5"/>
+                <c:lvl>
+                  <c:pt idx="0">
+                    <c:v>FY26</c:v>
+                  </c:pt>
+                  <c:pt idx="1">
+                    <c:v>FY27</c:v>
+                  </c:pt>
+                  <c:pt idx="2">
+                    <c:v>FY28</c:v>
+                  </c:pt>
+                  <c:pt idx="3">
+                    <c:v>FY29</c:v>
+                  </c:pt>
+                  <c:pt idx="4">
+                    <c:v>FY30</c:v>
+                  </c:pt>
+                </c:lvl>
+              </c:multiLvlStrCache>
+            </c:multiLvlStrRef>
+          </c:cat>
+          <c:val>
+            <c:numRef>
+              <c:f>Sheet1!$B$2:$B$6</c:f>
+              <c:numCache>
+                <c:formatCode>General</c:formatCode>
+                <c:ptCount val="5"/>
+                <c:pt idx="0">
+                  <c:v>0.08</c:v>
+                </c:pt>
+                <c:pt idx="1">
+                  <c:v>3.8</c:v>
+                </c:pt>
+                <c:pt idx="2">
+                  <c:v>8.3</c:v>
+                </c:pt>
+                <c:pt idx="3">
+                  <c:v>11.3</c:v>
+                </c:pt>
+                <c:pt idx="4">
+                  <c:v>16</c:v>
+                </c:pt>
+              </c:numCache>
+            </c:numRef>
+          </c:val>
+        </c:ser>
+        <c:dLbls>
+          <c:numFmt formatCode="#,##0" sourceLinked="0"/>
+          <c:txPr>
+            <a:bodyPr/>
+            <a:lstStyle/>
+            <a:p>
+              <a:pPr>
+                <a:defRPr b="0" i="0" strike="noStrike" sz="950" u="none">
+                  <a:solidFill>
+                    <a:srgbClr val="334155"/>
+                  </a:solidFill>
+                  <a:latin typeface="Calibri"/>
+                </a:defRPr>
+              </a:pPr>
+            </a:p>
+          </c:txPr>
+          <c:showLegendKey val="0"/>
+          <c:showVal val="1"/>
+          <c:showCatName val="0"/>
+          <c:showSerName val="0"/>
+          <c:showPercent val="0"/>
+          <c:showBubbleSize val="0"/>
+          <c:showLeaderLines val="0"/>
+        </c:dLbls>
+        <c:gapWidth val="150"/>
+        <c:overlap val="0"/>
+        <c:axId val="2094734554"/>
+        <c:axId val="2094734552"/>
+        <c:axId val="2094734556"/>
+      </c:barChart>
+      <c:catAx>
+        <c:axId val="2094734554"/>
+        <c:scaling>
+          <c:orientation val="minMax"/>
+        </c:scaling>
+        <c:delete val="0"/>
+        <c:axPos val="b"/>
+        <c:numFmt formatCode="General" sourceLinked="1"/>
+        <c:majorTickMark val="out"/>
+        <c:minorTickMark val="none"/>
+        <c:tickLblPos val="low"/>
+        <c:spPr>
+          <a:ln w="12700" cap="flat">
+            <a:solidFill>
+              <a:srgbClr val="888888"/>
+            </a:solidFill>
+            <a:prstDash val="solid"/>
+            <a:round/>
+          </a:ln>
+        </c:spPr>
+        <c:txPr>
+          <a:bodyPr/>
+          <a:lstStyle/>
+          <a:p>
+            <a:pPr>
+              <a:defRPr sz="1050" b="0" i="0" u="none" strike="noStrike">
+                <a:solidFill>
+                  <a:srgbClr val="334155"/>
+                </a:solidFill>
+                <a:latin typeface="Calibri"/>
+              </a:defRPr>
+            </a:pPr>
+            <a:endParaRPr lang="en-US"/>
+          </a:p>
+        </c:txPr>
+        <c:crossAx val="2094734552"/>
+        <c:crosses val="autoZero"/>
+        <c:auto val="1"/>
+        <c:lblAlgn val="ctr"/>
+        <c:noMultiLvlLbl val="1"/>
+      </c:catAx>
+      <c:valAx>
+        <c:axId val="2094734552"/>
+        <c:scaling>
+          <c:orientation val="minMax"/>
+          <c:max val="19"/>
+        </c:scaling>
+        <c:delete val="1"/>
+        <c:axPos val="l"/>
+        <c:numFmt formatCode="General" sourceLinked="0"/>
+        <c:majorTickMark val="out"/>
+        <c:minorTickMark val="none"/>
+        <c:tickLblPos val="nextTo"/>
+        <c:spPr>
+          <a:ln w="12700" cap="flat">
+            <a:solidFill>
+              <a:srgbClr val="888888"/>
+            </a:solidFill>
+            <a:prstDash val="solid"/>
+            <a:round/>
+          </a:ln>
+        </c:spPr>
+        <c:txPr>
+          <a:bodyPr/>
+          <a:lstStyle/>
+          <a:p>
+            <a:pPr>
+              <a:defRPr sz="1200" b="0" i="0" u="none" strike="noStrike">
+                <a:solidFill>
+                  <a:srgbClr val="000000"/>
+                </a:solidFill>
+                <a:latin typeface="Arial"/>
+              </a:defRPr>
+            </a:pPr>
+            <a:endParaRPr lang="en-US"/>
+          </a:p>
+        </c:txPr>
+        <c:crossAx val="2094734554"/>
+        <c:crosses val="autoZero"/>
+        <c:crossBetween val="between"/>
+      </c:valAx>
+      <c:spPr>
+        <a:noFill/>
+        <a:ln>
+          <a:noFill/>
+        </a:ln>
+        <a:effectLst/>
+      </c:spPr>
+    </c:plotArea>
+    <c:plotVisOnly val="1"/>
+    <c:dispBlanksAs val="span"/>
+  </c:chart>
+  <c:spPr>
+    <a:noFill/>
+    <a:ln>
+      <a:noFill/>
+    </a:ln>
+    <a:effectLst/>
+  </c:spPr>
+  <c:externalData r:id="rId1">
+    <c:autoUpdate val="0"/>
+  </c:externalData>
+</c:chartSpace>
+</file>
+
+<file path=ppt/charts/chart2.xml><?xml version="1.0" encoding="utf-8"?>
+<c:chartSpace xmlns:c="http://schemas.openxmlformats.org/drawingml/2006/chart" xmlns:a="http://schemas.openxmlformats.org/drawingml/2006/main" xmlns:r="http://schemas.openxmlformats.org/officeDocument/2006/relationships">
+  <c:date1904 val="0"/>
+  <c:roundedCorners val="1"/>
+  <c:chart>
     <c:title>
       <c:tx>
         <c:rich>
@@ -395,7 +1180,7 @@
 </c:chartSpace>
 </file>
 
-<file path=ppt/charts/chart2.xml><?xml version="1.0" encoding="utf-8"?>
+<file path=ppt/charts/chart3.xml><?xml version="1.0" encoding="utf-8"?>
 <c:chartSpace xmlns:c="http://schemas.openxmlformats.org/drawingml/2006/chart" xmlns:a="http://schemas.openxmlformats.org/drawingml/2006/main" xmlns:r="http://schemas.openxmlformats.org/officeDocument/2006/relationships">
   <c:date1904 val="0"/>
   <c:roundedCorners val="1"/>
@@ -871,7 +1656,7 @@
 </c:chartSpace>
 </file>
 
-<file path=ppt/charts/chart3.xml><?xml version="1.0" encoding="utf-8"?>
+<file path=ppt/charts/chart4.xml><?xml version="1.0" encoding="utf-8"?>
 <c:chartSpace xmlns:c="http://schemas.openxmlformats.org/drawingml/2006/chart" xmlns:a="http://schemas.openxmlformats.org/drawingml/2006/main" xmlns:r="http://schemas.openxmlformats.org/officeDocument/2006/relationships">
   <c:date1904 val="0"/>
   <c:roundedCorners val="1"/>
@@ -1347,7 +2132,7 @@
 </c:chartSpace>
 </file>
 
-<file path=ppt/charts/chart4.xml><?xml version="1.0" encoding="utf-8"?>
+<file path=ppt/charts/chart5.xml><?xml version="1.0" encoding="utf-8"?>
 <c:chartSpace xmlns:c="http://schemas.openxmlformats.org/drawingml/2006/chart" xmlns:a="http://schemas.openxmlformats.org/drawingml/2006/main" xmlns:r="http://schemas.openxmlformats.org/officeDocument/2006/relationships">
   <c:date1904 val="0"/>
   <c:roundedCorners val="1"/>
@@ -1457,10 +2242,10 @@
                 <c:formatCode>General</c:formatCode>
                 <c:ptCount val="12"/>
                 <c:pt idx="0">
-                  <c:v>0.17</c:v>
+                  <c:v>0.18</c:v>
                 </c:pt>
                 <c:pt idx="1">
-                  <c:v>0.2</c:v>
+                  <c:v>0.19</c:v>
                 </c:pt>
                 <c:pt idx="2">
                   <c:v>0.23</c:v>
@@ -1823,7 +2608,7 @@
 </c:chartSpace>
 </file>
 
-<file path=ppt/charts/chart5.xml><?xml version="1.0" encoding="utf-8"?>
+<file path=ppt/charts/chart6.xml><?xml version="1.0" encoding="utf-8"?>
 <c:chartSpace xmlns:c="http://schemas.openxmlformats.org/drawingml/2006/chart" xmlns:a="http://schemas.openxmlformats.org/drawingml/2006/main" xmlns:r="http://schemas.openxmlformats.org/officeDocument/2006/relationships">
   <c:date1904 val="0"/>
   <c:roundedCorners val="1"/>
@@ -2100,22 +2885,22 @@
               <c:strCache>
                 <c:ptCount val="6"/>
                 <c:pt idx="0">
-                  <c:v>People (incl. 2 hires)</c:v>
+                  <c:v>Salary</c:v>
                 </c:pt>
                 <c:pt idx="1">
-                  <c:v>Facilities</c:v>
+                  <c:v>Rent</c:v>
                 </c:pt>
                 <c:pt idx="2">
-                  <c:v>Professional and board</c:v>
+                  <c:v>Professional</c:v>
                 </c:pt>
                 <c:pt idx="3">
-                  <c:v>Technology and data</c:v>
+                  <c:v>Sitting fees</c:v>
                 </c:pt>
                 <c:pt idx="4">
-                  <c:v>Travel and admin</c:v>
+                  <c:v>Travel</c:v>
                 </c:pt>
                 <c:pt idx="5">
-                  <c:v>Regulatory and depr.</c:v>
+                  <c:v>Other heads</c:v>
                 </c:pt>
               </c:strCache>
             </c:strRef>
@@ -2126,22 +2911,22 @@
               <c:numCache>
                 <c:ptCount val="6"/>
                 <c:pt idx="0">
-                  <c:v>3.64</c:v>
+                  <c:v>71.99</c:v>
                 </c:pt>
                 <c:pt idx="1">
-                  <c:v>0.62</c:v>
+                  <c:v>14.65</c:v>
                 </c:pt>
                 <c:pt idx="2">
-                  <c:v>0.34</c:v>
+                  <c:v>6.01</c:v>
                 </c:pt>
                 <c:pt idx="3">
-                  <c:v>0.34</c:v>
+                  <c:v>5.5</c:v>
                 </c:pt>
                 <c:pt idx="4">
-                  <c:v>0.16</c:v>
+                  <c:v>3.7</c:v>
                 </c:pt>
                 <c:pt idx="5">
-                  <c:v>0.14</c:v>
+                  <c:v>21.43</c:v>
                 </c:pt>
               </c:numCache>
             </c:numRef>
@@ -2194,7 +2979,7 @@
 </c:chartSpace>
 </file>
 
-<file path=ppt/charts/chart6.xml><?xml version="1.0" encoding="utf-8"?>
+<file path=ppt/charts/chart7.xml><?xml version="1.0" encoding="utf-8"?>
 <c:chartSpace xmlns:c="http://schemas.openxmlformats.org/drawingml/2006/chart" xmlns:a="http://schemas.openxmlformats.org/drawingml/2006/main" xmlns:r="http://schemas.openxmlformats.org/officeDocument/2006/relationships">
   <c:date1904 val="0"/>
   <c:roundedCorners val="1"/>
@@ -2639,7 +3424,7 @@
 </c:chartSpace>
 </file>
 
-<file path=ppt/charts/chart7.xml><?xml version="1.0" encoding="utf-8"?>
+<file path=ppt/charts/chart8.xml><?xml version="1.0" encoding="utf-8"?>
 <c:chartSpace xmlns:c="http://schemas.openxmlformats.org/drawingml/2006/chart" xmlns:a="http://schemas.openxmlformats.org/drawingml/2006/main" xmlns:r="http://schemas.openxmlformats.org/officeDocument/2006/relationships">
   <c:date1904 val="0"/>
   <c:roundedCorners val="1"/>
@@ -2974,7 +3759,7 @@
 </c:chartSpace>
 </file>
 
-<file path=ppt/charts/chart8.xml><?xml version="1.0" encoding="utf-8"?>
+<file path=ppt/charts/chart9.xml><?xml version="1.0" encoding="utf-8"?>
 <c:chartSpace xmlns:c="http://schemas.openxmlformats.org/drawingml/2006/chart" xmlns:a="http://schemas.openxmlformats.org/drawingml/2006/main" xmlns:r="http://schemas.openxmlformats.org/officeDocument/2006/relationships">
   <c:date1904 val="0"/>
   <c:roundedCorners val="1"/>
@@ -3176,248 +3961,6 @@
         <c:majorTickMark val="out"/>
         <c:minorTickMark val="none"/>
         <c:tickLblPos val="low"/>
-        <c:spPr>
-          <a:ln w="12700" cap="flat">
-            <a:solidFill>
-              <a:srgbClr val="888888"/>
-            </a:solidFill>
-            <a:prstDash val="solid"/>
-            <a:round/>
-          </a:ln>
-        </c:spPr>
-        <c:txPr>
-          <a:bodyPr/>
-          <a:lstStyle/>
-          <a:p>
-            <a:pPr>
-              <a:defRPr sz="1200" b="0" i="0" u="none" strike="noStrike">
-                <a:solidFill>
-                  <a:srgbClr val="000000"/>
-                </a:solidFill>
-                <a:latin typeface="Arial"/>
-              </a:defRPr>
-            </a:pPr>
-            <a:endParaRPr lang="en-US"/>
-          </a:p>
-        </c:txPr>
-        <c:crossAx val="2094734554"/>
-        <c:crosses val="autoZero"/>
-        <c:crossBetween val="between"/>
-      </c:valAx>
-      <c:spPr>
-        <a:noFill/>
-        <a:ln>
-          <a:noFill/>
-        </a:ln>
-        <a:effectLst/>
-      </c:spPr>
-    </c:plotArea>
-    <c:plotVisOnly val="1"/>
-    <c:dispBlanksAs val="span"/>
-  </c:chart>
-  <c:spPr>
-    <a:noFill/>
-    <a:ln>
-      <a:noFill/>
-    </a:ln>
-    <a:effectLst/>
-  </c:spPr>
-  <c:externalData r:id="rId1">
-    <c:autoUpdate val="0"/>
-  </c:externalData>
-</c:chartSpace>
-</file>
-
-<file path=ppt/charts/chart9.xml><?xml version="1.0" encoding="utf-8"?>
-<c:chartSpace xmlns:c="http://schemas.openxmlformats.org/drawingml/2006/chart" xmlns:a="http://schemas.openxmlformats.org/drawingml/2006/main" xmlns:r="http://schemas.openxmlformats.org/officeDocument/2006/relationships">
-  <c:date1904 val="0"/>
-  <c:roundedCorners val="1"/>
-  <c:chart>
-    <c:autoTitleDeleted val="1"/>
-    <c:plotArea>
-      <c:layout/>
-      <c:barChart>
-        <c:barDir val="col"/>
-        <c:grouping val="clustered"/>
-        <c:varyColors val="0"/>
-        <c:ser>
-          <c:idx val="0"/>
-          <c:order val="0"/>
-          <c:tx>
-            <c:strRef>
-              <c:f>Sheet1!$B$1</c:f>
-              <c:strCache>
-                <c:ptCount val="1"/>
-                <c:pt idx="0">
-                  <c:v>ACER rating revenue</c:v>
-                </c:pt>
-              </c:strCache>
-            </c:strRef>
-          </c:tx>
-          <c:spPr>
-            <a:solidFill>
-              <a:srgbClr val="0F766E"/>
-            </a:solidFill>
-            <a:effectLst/>
-          </c:spPr>
-          <c:invertIfNegative val="0"/>
-          <c:dLbls>
-            <c:numFmt formatCode="#,##0" sourceLinked="0"/>
-            <c:txPr>
-              <a:bodyPr/>
-              <a:lstStyle/>
-              <a:p>
-                <a:pPr>
-                  <a:defRPr b="0" i="0" strike="noStrike" sz="950" u="none">
-                    <a:solidFill>
-                      <a:srgbClr val="334155"/>
-                    </a:solidFill>
-                    <a:latin typeface="Calibri"/>
-                  </a:defRPr>
-                </a:pPr>
-              </a:p>
-            </c:txPr>
-            <c:showLegendKey val="0"/>
-            <c:showVal val="1"/>
-            <c:showCatName val="0"/>
-            <c:showSerName val="0"/>
-            <c:showPercent val="0"/>
-            <c:showBubbleSize val="0"/>
-            <c:showLeaderLines val="0"/>
-          </c:dLbls>
-          <c:cat>
-            <c:multiLvlStrRef>
-              <c:f>Sheet1!$A$2:$A$6</c:f>
-              <c:multiLvlStrCache>
-                <c:ptCount val="5"/>
-                <c:lvl>
-                  <c:pt idx="0">
-                    <c:v>FY26</c:v>
-                  </c:pt>
-                  <c:pt idx="1">
-                    <c:v>FY27</c:v>
-                  </c:pt>
-                  <c:pt idx="2">
-                    <c:v>FY28</c:v>
-                  </c:pt>
-                  <c:pt idx="3">
-                    <c:v>FY29</c:v>
-                  </c:pt>
-                  <c:pt idx="4">
-                    <c:v>FY30</c:v>
-                  </c:pt>
-                </c:lvl>
-              </c:multiLvlStrCache>
-            </c:multiLvlStrRef>
-          </c:cat>
-          <c:val>
-            <c:numRef>
-              <c:f>Sheet1!$B$2:$B$6</c:f>
-              <c:numCache>
-                <c:formatCode>General</c:formatCode>
-                <c:ptCount val="5"/>
-                <c:pt idx="0">
-                  <c:v>0.08</c:v>
-                </c:pt>
-                <c:pt idx="1">
-                  <c:v>3.8</c:v>
-                </c:pt>
-                <c:pt idx="2">
-                  <c:v>8.3</c:v>
-                </c:pt>
-                <c:pt idx="3">
-                  <c:v>11.3</c:v>
-                </c:pt>
-                <c:pt idx="4">
-                  <c:v>16</c:v>
-                </c:pt>
-              </c:numCache>
-            </c:numRef>
-          </c:val>
-        </c:ser>
-        <c:dLbls>
-          <c:numFmt formatCode="#,##0" sourceLinked="0"/>
-          <c:txPr>
-            <a:bodyPr/>
-            <a:lstStyle/>
-            <a:p>
-              <a:pPr>
-                <a:defRPr b="0" i="0" strike="noStrike" sz="950" u="none">
-                  <a:solidFill>
-                    <a:srgbClr val="334155"/>
-                  </a:solidFill>
-                  <a:latin typeface="Calibri"/>
-                </a:defRPr>
-              </a:pPr>
-            </a:p>
-          </c:txPr>
-          <c:showLegendKey val="0"/>
-          <c:showVal val="1"/>
-          <c:showCatName val="0"/>
-          <c:showSerName val="0"/>
-          <c:showPercent val="0"/>
-          <c:showBubbleSize val="0"/>
-          <c:showLeaderLines val="0"/>
-        </c:dLbls>
-        <c:gapWidth val="150"/>
-        <c:overlap val="0"/>
-        <c:axId val="2094734554"/>
-        <c:axId val="2094734552"/>
-        <c:axId val="2094734556"/>
-      </c:barChart>
-      <c:catAx>
-        <c:axId val="2094734554"/>
-        <c:scaling>
-          <c:orientation val="minMax"/>
-        </c:scaling>
-        <c:delete val="0"/>
-        <c:axPos val="b"/>
-        <c:numFmt formatCode="General" sourceLinked="1"/>
-        <c:majorTickMark val="out"/>
-        <c:minorTickMark val="none"/>
-        <c:tickLblPos val="low"/>
-        <c:spPr>
-          <a:ln w="12700" cap="flat">
-            <a:solidFill>
-              <a:srgbClr val="888888"/>
-            </a:solidFill>
-            <a:prstDash val="solid"/>
-            <a:round/>
-          </a:ln>
-        </c:spPr>
-        <c:txPr>
-          <a:bodyPr/>
-          <a:lstStyle/>
-          <a:p>
-            <a:pPr>
-              <a:defRPr sz="1050" b="0" i="0" u="none" strike="noStrike">
-                <a:solidFill>
-                  <a:srgbClr val="334155"/>
-                </a:solidFill>
-                <a:latin typeface="Calibri"/>
-              </a:defRPr>
-            </a:pPr>
-            <a:endParaRPr lang="en-US"/>
-          </a:p>
-        </c:txPr>
-        <c:crossAx val="2094734552"/>
-        <c:crosses val="autoZero"/>
-        <c:auto val="1"/>
-        <c:lblAlgn val="ctr"/>
-        <c:noMultiLvlLbl val="1"/>
-      </c:catAx>
-      <c:valAx>
-        <c:axId val="2094734552"/>
-        <c:scaling>
-          <c:orientation val="minMax"/>
-          <c:max val="19"/>
-        </c:scaling>
-        <c:delete val="1"/>
-        <c:axPos val="l"/>
-        <c:numFmt formatCode="General" sourceLinked="0"/>
-        <c:majorTickMark val="out"/>
-        <c:minorTickMark val="none"/>
-        <c:tickLblPos val="nextTo"/>
         <c:spPr>
           <a:ln w="12700" cap="flat">
             <a:solidFill>
@@ -8117,28 +8660,24 @@
         </p:nvSpPr>
         <p:spPr>
           <a:xfrm>
-            <a:off x="566928" y="3383280"/>
-            <a:ext cx="10972800" cy="2286000"/>
-          </a:xfrm>
-          <a:prstGeom prst="rect">
-            <a:avLst/>
-          </a:prstGeom>
-          <a:noFill/>
-          <a:ln/>
-        </p:spPr>
-        <p:txBody>
-          <a:bodyPr wrap="square" rtlCol="0" anchor="t"/>
-          <a:lstStyle/>
-          <a:p>
-            <a:pPr marL="177800" indent="-177800">
-              <a:spcAft>
-                <a:spcPts val="700"/>
-              </a:spcAft>
-              <a:buSzPct val="100000"/>
-              <a:buChar char="•"/>
-            </a:pPr>
-            <a:r>
-              <a:rPr lang="en-US" sz="1400" dirty="0">
+            <a:off x="566928" y="3200400"/>
+            <a:ext cx="6949440" cy="274320"/>
+          </a:xfrm>
+          <a:prstGeom prst="rect">
+            <a:avLst/>
+          </a:prstGeom>
+          <a:noFill/>
+          <a:ln/>
+        </p:spPr>
+        <p:txBody>
+          <a:bodyPr wrap="square" rtlCol="0" anchor="ctr"/>
+          <a:lstStyle/>
+          <a:p>
+            <a:pPr indent="0" marL="0">
+              <a:buNone/>
+            </a:pPr>
+            <a:r>
+              <a:rPr lang="en-US" sz="1200" b="1" dirty="0">
                 <a:solidFill>
                   <a:srgbClr val="334155"/>
                 </a:solidFill>
@@ -8146,20 +8685,54 @@
                 <a:ea typeface="Calibri" pitchFamily="34" charset="-122"/>
                 <a:cs typeface="Calibri" pitchFamily="34" charset="-120"/>
               </a:rPr>
-              <a:t>Income is carried by interest on the deposit corpus, not by the rating business. That is a capital story, not yet an operating one.</a:t>
-            </a:r>
-            <a:endParaRPr lang="en-US" sz="1400" dirty="0"/>
-          </a:p>
-          <a:p>
-            <a:pPr marL="177800" indent="-177800">
-              <a:spcAft>
-                <a:spcPts val="700"/>
-              </a:spcAft>
-              <a:buSzPct val="100000"/>
-              <a:buChar char="•"/>
-            </a:pPr>
-            <a:r>
-              <a:rPr lang="en-US" sz="1400" dirty="0">
+              <a:t>Actual monthly income and expense, from the books (Rs Cr)</a:t>
+            </a:r>
+            <a:endParaRPr lang="en-US" sz="1200" dirty="0"/>
+          </a:p>
+        </p:txBody>
+      </p:sp>
+      <p:graphicFrame>
+        <p:nvGraphicFramePr>
+          <p:cNvPr id="23" name="Chart 0" descr=""/>
+          <p:cNvGraphicFramePr/>
+          <p:nvPr/>
+        </p:nvGraphicFramePr>
+        <p:xfrm>
+          <a:off x="566928" y="3474720"/>
+          <a:ext cx="6766560" cy="2697480"/>
+        </p:xfrm>
+        <a:graphic xmlns:a="http://schemas.openxmlformats.org/drawingml/2006/main">
+          <a:graphicData uri="http://schemas.openxmlformats.org/drawingml/2006/chart">
+            <c:chart xmlns:c="http://schemas.openxmlformats.org/drawingml/2006/chart" r:id="rId1"/>
+          </a:graphicData>
+        </a:graphic>
+      </p:graphicFrame>
+      <p:sp>
+        <p:nvSpPr>
+          <p:cNvPr id="24" name="Text 21"/>
+          <p:cNvSpPr/>
+          <p:nvPr/>
+        </p:nvSpPr>
+        <p:spPr>
+          <a:xfrm>
+            <a:off x="7635240" y="3566160"/>
+            <a:ext cx="3977640" cy="2377440"/>
+          </a:xfrm>
+          <a:prstGeom prst="rect">
+            <a:avLst/>
+          </a:prstGeom>
+          <a:noFill/>
+          <a:ln/>
+        </p:spPr>
+        <p:txBody>
+          <a:bodyPr wrap="square" rtlCol="0" anchor="t"/>
+          <a:lstStyle/>
+          <a:p>
+            <a:pPr indent="0" marL="0">
+              <a:buNone/>
+            </a:pPr>
+            <a:r>
+              <a:rPr lang="en-US" sz="1350" dirty="0">
                 <a:solidFill>
                   <a:srgbClr val="334155"/>
                 </a:solidFill>
@@ -8167,67 +8740,46 @@
                 <a:ea typeface="Calibri" pitchFamily="34" charset="-122"/>
                 <a:cs typeface="Calibri" pitchFamily="34" charset="-120"/>
               </a:rPr>
-              <a:t>The Rs 25 Cr net worth barrier that stops most new entrants is already met and parked in fixed deposits.</a:t>
-            </a:r>
-            <a:endParaRPr lang="en-US" sz="1400" dirty="0"/>
-          </a:p>
-          <a:p>
-            <a:pPr marL="177800" indent="-177800">
-              <a:spcAft>
-                <a:spcPts val="700"/>
-              </a:spcAft>
-              <a:buSzPct val="100000"/>
-              <a:buChar char="•"/>
-            </a:pPr>
-            <a:r>
-              <a:rPr lang="en-US" sz="1400" dirty="0">
-                <a:solidFill>
-                  <a:srgbClr val="334155"/>
+              <a:t>Income sat around Rs 14 to 15 L a month, almost all FD interest, while expense climbed past it as the team grew. Ratings income appears only in the last few months. Every value is booked.</a:t>
+            </a:r>
+            <a:endParaRPr lang="en-US" sz="1350" dirty="0"/>
+          </a:p>
+        </p:txBody>
+      </p:sp>
+      <p:sp>
+        <p:nvSpPr>
+          <p:cNvPr id="25" name="Text 22"/>
+          <p:cNvSpPr/>
+          <p:nvPr/>
+        </p:nvSpPr>
+        <p:spPr>
+          <a:xfrm>
+            <a:off x="566928" y="6446520"/>
+            <a:ext cx="11064240" cy="301752"/>
+          </a:xfrm>
+          <a:prstGeom prst="rect">
+            <a:avLst/>
+          </a:prstGeom>
+          <a:noFill/>
+          <a:ln/>
+        </p:spPr>
+        <p:txBody>
+          <a:bodyPr wrap="square" rtlCol="0" anchor="ctr"/>
+          <a:lstStyle/>
+          <a:p>
+            <a:pPr indent="0" marL="0">
+              <a:buNone/>
+            </a:pPr>
+            <a:r>
+              <a:rPr lang="en-US" sz="900" i="1" dirty="0">
+                <a:solidFill>
+                  <a:srgbClr val="94A3B8"/>
                 </a:solidFill>
                 <a:latin typeface="Calibri" pitchFamily="34" charset="0"/>
                 <a:ea typeface="Calibri" pitchFamily="34" charset="-122"/>
                 <a:cs typeface="Calibri" pitchFamily="34" charset="-120"/>
               </a:rPr>
-              <a:t>Operating revenue has just begun to inflect, from Rs 8 L in all of FY26 to Rs 28.5 L in the first quarter of FY27.</a:t>
-            </a:r>
-            <a:endParaRPr lang="en-US" sz="1400" dirty="0"/>
-          </a:p>
-        </p:txBody>
-      </p:sp>
-      <p:sp>
-        <p:nvSpPr>
-          <p:cNvPr id="23" name="Text 21"/>
-          <p:cNvSpPr/>
-          <p:nvPr/>
-        </p:nvSpPr>
-        <p:spPr>
-          <a:xfrm>
-            <a:off x="566928" y="6446520"/>
-            <a:ext cx="11064240" cy="301752"/>
-          </a:xfrm>
-          <a:prstGeom prst="rect">
-            <a:avLst/>
-          </a:prstGeom>
-          <a:noFill/>
-          <a:ln/>
-        </p:spPr>
-        <p:txBody>
-          <a:bodyPr wrap="square" rtlCol="0" anchor="ctr"/>
-          <a:lstStyle/>
-          <a:p>
-            <a:pPr indent="0" marL="0">
-              <a:buNone/>
-            </a:pPr>
-            <a:r>
-              <a:rPr lang="en-US" sz="900" i="1" dirty="0">
-                <a:solidFill>
-                  <a:srgbClr val="94A3B8"/>
-                </a:solidFill>
-                <a:latin typeface="Calibri" pitchFamily="34" charset="0"/>
-                <a:ea typeface="Calibri" pitchFamily="34" charset="-122"/>
-                <a:cs typeface="Calibri" pitchFamily="34" charset="-120"/>
-              </a:rPr>
-              <a:t>Source: Internal [1]. SEBI net worth requirement [10].</a:t>
+              <a:t>Source: Internal monthly ledger, Apr 2025 to Jun 2026 [1]. SEBI net worth requirement [10].</a:t>
             </a:r>
             <a:endParaRPr lang="en-US" sz="900" dirty="0"/>
           </a:p>
@@ -11906,7 +12458,7 @@
                 <a:ea typeface="Calibri" pitchFamily="34" charset="-122"/>
                 <a:cs typeface="Calibri" pitchFamily="34" charset="-120"/>
               </a:rPr>
-              <a:t>Green area is total monthly income, FD plus ratings. The dark line is all in monthly expense. Where green rises above the line, the month is cash positive.</a:t>
+              <a:t>Green area is total monthly income, FD plus ratings. The dark line is all in monthly expense. The first quarter, Apr to Jun, is actual; the rest is projected. Where green rises above the line, the month is cash positive.</a:t>
             </a:r>
             <a:endParaRPr lang="en-US" sz="1400" dirty="0"/>
           </a:p>
@@ -12783,7 +13335,7 @@
                           <a:ea typeface="Calibri" pitchFamily="34" charset="-122"/>
                           <a:cs typeface="Calibri" pitchFamily="34" charset="-120"/>
                         </a:rPr>
-                        <a:t>Q1 (Apr to Jun)</a:t>
+                        <a:t>Q1 (Apr to Jun) actual</a:t>
                       </a:r>
                       <a:endParaRPr lang="en-US" sz="1200" dirty="0">
                         <a:latin typeface="Calibri" charset="0"/>
@@ -14164,7 +14716,7 @@
               <a:buNone/>
             </a:pPr>
             <a:r>
-              <a:rPr lang="en-US" sz="1300" b="1" dirty="0">
+              <a:rPr lang="en-US" sz="1200" b="1" dirty="0">
                 <a:solidFill>
                   <a:srgbClr val="334155"/>
                 </a:solidFill>
@@ -14172,9 +14724,9 @@
                 <a:ea typeface="Calibri" pitchFamily="34" charset="-122"/>
                 <a:cs typeface="Calibri" pitchFamily="34" charset="-120"/>
               </a:rPr>
-              <a:t>FY27 cost base, Rs 5.24 Cr by head</a:t>
-            </a:r>
-            <a:endParaRPr lang="en-US" sz="1300" dirty="0"/>
+              <a:t>FY27 actual spend to date, by ledger head (Rs Lakh)</a:t>
+            </a:r>
+            <a:endParaRPr lang="en-US" sz="1200" dirty="0"/>
           </a:p>
         </p:txBody>
       </p:sp>
@@ -14223,7 +14775,7 @@
               <a:buChar char="•"/>
             </a:pPr>
             <a:r>
-              <a:rPr lang="en-US" sz="1350" dirty="0">
+              <a:rPr lang="en-US" sz="1300" dirty="0">
                 <a:solidFill>
                   <a:srgbClr val="334155"/>
                 </a:solidFill>
@@ -14231,9 +14783,9 @@
                 <a:ea typeface="Calibri" pitchFamily="34" charset="-122"/>
                 <a:cs typeface="Calibri" pitchFamily="34" charset="-120"/>
               </a:rPr>
-              <a:t>People are 69% of cost, the single lever the Board controls. The two new hires add Rs 0.64 Cr in FY27; the rest of the base is largely fixed.</a:t>
-            </a:r>
-            <a:endParaRPr lang="en-US" sz="1350" dirty="0"/>
+              <a:t>Salary is 58% of actual spend to date and rises further as the two new hires annualise. Q1 P&amp;L above is booked actual; Q2 to Q4 are projected. Full year cost base is budgeted at Rs 5.24 Cr.</a:t>
+            </a:r>
+            <a:endParaRPr lang="en-US" sz="1300" dirty="0"/>
           </a:p>
         </p:txBody>
       </p:sp>
@@ -14270,7 +14822,7 @@
                 <a:ea typeface="Calibri" pitchFamily="34" charset="-122"/>
                 <a:cs typeface="Calibri" pitchFamily="34" charset="-120"/>
               </a:rPr>
-              <a:t>Source: quarterly build and cost heads modelled from Internal run rate [1] and BLR assumptions [2].</a:t>
+              <a:t>Source: cost heads are Internal actuals to 21 Jul [1]; quarterly build uses Internal run rate [1] and BLR assumptions [2].</a:t>
             </a:r>
             <a:endParaRPr lang="en-US" sz="900" dirty="0"/>
           </a:p>

</xml_diff>

<commit_message>
Add doability evidence (Rs 1600 Cr/mo vs market) + swarm-built executive deck
Replaced market-share pie with a doability exhibit on web and main PPT: ACER's Rs 19,200 Cr/yr target is ~0.27pct of India bank credit, ~1.9pct of annual bond issuance, ~1pct of Brickwork's lifetime rated debt; capacity is not the constraint. Sources RBI/CRISIL/Brickwork added. New board/AOP_exec_deck.pptx built by an 8-agent swarm (10 slides, action titles + speaker notes, adversarially checked).
</commit_message>
<xml_diff>
--- a/board/AOP_board_presentation.pptx
+++ b/board/AOP_board_presentation.pptx
@@ -385,418 +385,6 @@
         <a:effectLst/>
       </c:spPr>
     </c:plotArea>
-    <c:plotVisOnly val="1"/>
-    <c:dispBlanksAs val="span"/>
-  </c:chart>
-  <c:spPr>
-    <a:noFill/>
-    <a:ln>
-      <a:noFill/>
-    </a:ln>
-    <a:effectLst/>
-  </c:spPr>
-  <c:externalData r:id="rId1">
-    <c:autoUpdate val="0"/>
-  </c:externalData>
-</c:chartSpace>
-</file>
-
-<file path=ppt/charts/chart10.xml><?xml version="1.0" encoding="utf-8"?>
-<c:chartSpace xmlns:c="http://schemas.openxmlformats.org/drawingml/2006/chart" xmlns:a="http://schemas.openxmlformats.org/drawingml/2006/main" xmlns:r="http://schemas.openxmlformats.org/officeDocument/2006/relationships">
-  <c:date1904 val="0"/>
-  <c:roundedCorners val="1"/>
-  <c:chart>
-    <c:autoTitleDeleted val="1"/>
-    <c:plotArea>
-      <c:layout/>
-      <c:doughnutChart>
-        <c:varyColors val="1"/>
-        <c:ser>
-          <c:idx val="0"/>
-          <c:order val="0"/>
-          <c:tx>
-            <c:strRef>
-              <c:f>Sheet1!$B$1</c:f>
-              <c:strCache>
-                <c:ptCount val="1"/>
-                <c:pt idx="0">
-                  <c:v>Share</c:v>
-                </c:pt>
-              </c:strCache>
-            </c:strRef>
-          </c:tx>
-          <c:spPr>
-            <a:solidFill>
-              <a:schemeClr val="accent1"/>
-            </a:solidFill>
-            <a:ln w="9525" cap="flat">
-              <a:solidFill>
-                <a:srgbClr val="F9F9F9"/>
-              </a:solidFill>
-              <a:prstDash val="solid"/>
-              <a:round/>
-            </a:ln>
-            <a:effectLst/>
-          </c:spPr>
-          <c:dPt>
-            <c:idx val="0"/>
-            <c:bubble3D val="0"/>
-            <c:spPr>
-              <a:solidFill>
-                <a:srgbClr val="1E4E79"/>
-              </a:solidFill>
-              <a:effectLst/>
-            </c:spPr>
-          </c:dPt>
-          <c:dPt>
-            <c:idx val="1"/>
-            <c:bubble3D val="0"/>
-            <c:spPr>
-              <a:solidFill>
-                <a:srgbClr val="356F9C"/>
-              </a:solidFill>
-              <a:effectLst/>
-            </c:spPr>
-          </c:dPt>
-          <c:dPt>
-            <c:idx val="2"/>
-            <c:bubble3D val="0"/>
-            <c:spPr>
-              <a:solidFill>
-                <a:srgbClr val="5F9BC0"/>
-              </a:solidFill>
-              <a:effectLst/>
-            </c:spPr>
-          </c:dPt>
-          <c:dPt>
-            <c:idx val="3"/>
-            <c:bubble3D val="0"/>
-            <c:spPr>
-              <a:solidFill>
-                <a:srgbClr val="93BDD6"/>
-              </a:solidFill>
-              <a:effectLst/>
-            </c:spPr>
-          </c:dPt>
-          <c:dPt>
-            <c:idx val="4"/>
-            <c:bubble3D val="0"/>
-            <c:spPr>
-              <a:solidFill>
-                <a:srgbClr val="0F766E"/>
-              </a:solidFill>
-              <a:effectLst/>
-            </c:spPr>
-          </c:dPt>
-          <c:dPt>
-            <c:idx val="5"/>
-            <c:bubble3D val="0"/>
-            <c:spPr>
-              <a:solidFill>
-                <a:srgbClr val="4CA596"/>
-              </a:solidFill>
-              <a:effectLst/>
-            </c:spPr>
-          </c:dPt>
-          <c:dPt>
-            <c:idx val="6"/>
-            <c:bubble3D val="0"/>
-            <c:spPr>
-              <a:solidFill>
-                <a:srgbClr val="C3CCD6"/>
-              </a:solidFill>
-              <a:effectLst/>
-            </c:spPr>
-          </c:dPt>
-          <c:dLbls>
-            <c:dLbl>
-              <c:idx val="0"/>
-              <c:numFmt formatCode="General" sourceLinked="0"/>
-              <c:spPr/>
-              <c:txPr>
-                <a:bodyPr/>
-                <a:lstStyle/>
-                <a:p>
-                  <a:pPr>
-                    <a:defRPr sz="1200" b="0" i="0" u="none" strike="noStrike">
-                      <a:solidFill>
-                        <a:srgbClr val="000000"/>
-                      </a:solidFill>
-                      <a:latin typeface="Arial"/>
-                    </a:defRPr>
-                  </a:pPr>
-                </a:p>
-              </c:txPr>
-              <c:showLegendKey val="0"/>
-              <c:showVal val="0"/>
-              <c:showCatName val="0"/>
-              <c:showSerName val="0"/>
-              <c:showPercent val="0"/>
-              <c:showBubbleSize val="0"/>
-            </c:dLbl>
-            <c:dLbl>
-              <c:idx val="1"/>
-              <c:numFmt formatCode="General" sourceLinked="0"/>
-              <c:spPr/>
-              <c:txPr>
-                <a:bodyPr/>
-                <a:lstStyle/>
-                <a:p>
-                  <a:pPr>
-                    <a:defRPr sz="1200" b="0" i="0" u="none" strike="noStrike">
-                      <a:solidFill>
-                        <a:srgbClr val="000000"/>
-                      </a:solidFill>
-                      <a:latin typeface="Arial"/>
-                    </a:defRPr>
-                  </a:pPr>
-                </a:p>
-              </c:txPr>
-              <c:showLegendKey val="0"/>
-              <c:showVal val="0"/>
-              <c:showCatName val="0"/>
-              <c:showSerName val="0"/>
-              <c:showPercent val="0"/>
-              <c:showBubbleSize val="0"/>
-            </c:dLbl>
-            <c:dLbl>
-              <c:idx val="2"/>
-              <c:numFmt formatCode="General" sourceLinked="0"/>
-              <c:spPr/>
-              <c:txPr>
-                <a:bodyPr/>
-                <a:lstStyle/>
-                <a:p>
-                  <a:pPr>
-                    <a:defRPr sz="1200" b="0" i="0" u="none" strike="noStrike">
-                      <a:solidFill>
-                        <a:srgbClr val="000000"/>
-                      </a:solidFill>
-                      <a:latin typeface="Arial"/>
-                    </a:defRPr>
-                  </a:pPr>
-                </a:p>
-              </c:txPr>
-              <c:showLegendKey val="0"/>
-              <c:showVal val="0"/>
-              <c:showCatName val="0"/>
-              <c:showSerName val="0"/>
-              <c:showPercent val="0"/>
-              <c:showBubbleSize val="0"/>
-            </c:dLbl>
-            <c:dLbl>
-              <c:idx val="3"/>
-              <c:numFmt formatCode="General" sourceLinked="0"/>
-              <c:spPr/>
-              <c:txPr>
-                <a:bodyPr/>
-                <a:lstStyle/>
-                <a:p>
-                  <a:pPr>
-                    <a:defRPr sz="1200" b="0" i="0" u="none" strike="noStrike">
-                      <a:solidFill>
-                        <a:srgbClr val="000000"/>
-                      </a:solidFill>
-                      <a:latin typeface="Arial"/>
-                    </a:defRPr>
-                  </a:pPr>
-                </a:p>
-              </c:txPr>
-              <c:showLegendKey val="0"/>
-              <c:showVal val="0"/>
-              <c:showCatName val="0"/>
-              <c:showSerName val="0"/>
-              <c:showPercent val="0"/>
-              <c:showBubbleSize val="0"/>
-            </c:dLbl>
-            <c:dLbl>
-              <c:idx val="4"/>
-              <c:numFmt formatCode="General" sourceLinked="0"/>
-              <c:spPr/>
-              <c:txPr>
-                <a:bodyPr/>
-                <a:lstStyle/>
-                <a:p>
-                  <a:pPr>
-                    <a:defRPr sz="1200" b="0" i="0" u="none" strike="noStrike">
-                      <a:solidFill>
-                        <a:srgbClr val="000000"/>
-                      </a:solidFill>
-                      <a:latin typeface="Arial"/>
-                    </a:defRPr>
-                  </a:pPr>
-                </a:p>
-              </c:txPr>
-              <c:showLegendKey val="0"/>
-              <c:showVal val="0"/>
-              <c:showCatName val="0"/>
-              <c:showSerName val="0"/>
-              <c:showPercent val="0"/>
-              <c:showBubbleSize val="0"/>
-            </c:dLbl>
-            <c:dLbl>
-              <c:idx val="5"/>
-              <c:numFmt formatCode="General" sourceLinked="0"/>
-              <c:spPr/>
-              <c:txPr>
-                <a:bodyPr/>
-                <a:lstStyle/>
-                <a:p>
-                  <a:pPr>
-                    <a:defRPr sz="1200" b="0" i="0" u="none" strike="noStrike">
-                      <a:solidFill>
-                        <a:srgbClr val="000000"/>
-                      </a:solidFill>
-                      <a:latin typeface="Arial"/>
-                    </a:defRPr>
-                  </a:pPr>
-                </a:p>
-              </c:txPr>
-              <c:showLegendKey val="0"/>
-              <c:showVal val="0"/>
-              <c:showCatName val="0"/>
-              <c:showSerName val="0"/>
-              <c:showPercent val="0"/>
-              <c:showBubbleSize val="0"/>
-            </c:dLbl>
-            <c:dLbl>
-              <c:idx val="6"/>
-              <c:numFmt formatCode="General" sourceLinked="0"/>
-              <c:spPr/>
-              <c:txPr>
-                <a:bodyPr/>
-                <a:lstStyle/>
-                <a:p>
-                  <a:pPr>
-                    <a:defRPr sz="1200" b="0" i="0" u="none" strike="noStrike">
-                      <a:solidFill>
-                        <a:srgbClr val="000000"/>
-                      </a:solidFill>
-                      <a:latin typeface="Arial"/>
-                    </a:defRPr>
-                  </a:pPr>
-                </a:p>
-              </c:txPr>
-              <c:showLegendKey val="0"/>
-              <c:showVal val="0"/>
-              <c:showCatName val="0"/>
-              <c:showSerName val="0"/>
-              <c:showPercent val="0"/>
-              <c:showBubbleSize val="0"/>
-            </c:dLbl>
-            <c:numFmt formatCode="General" sourceLinked="0"/>
-            <c:txPr>
-              <a:bodyPr/>
-              <a:lstStyle/>
-              <a:p>
-                <a:pPr>
-                  <a:defRPr sz="1800" b="0" i="0" u="none" strike="noStrike">
-                    <a:solidFill>
-                      <a:srgbClr val="000000"/>
-                    </a:solidFill>
-                    <a:latin typeface="Arial"/>
-                  </a:defRPr>
-                </a:pPr>
-              </a:p>
-            </c:txPr>
-            <c:showLegendKey val="0"/>
-            <c:showVal val="0"/>
-            <c:showCatName val="1"/>
-            <c:showSerName val="0"/>
-            <c:showPercent val="1"/>
-            <c:showBubbleSize val="0"/>
-            <c:showLeaderLines val="0"/>
-          </c:dLbls>
-          <c:cat>
-            <c:strRef>
-              <c:f>Sheet1!$A$2:$A$8</c:f>
-              <c:strCache>
-                <c:ptCount val="7"/>
-                <c:pt idx="0">
-                  <c:v>CRISIL 44%</c:v>
-                </c:pt>
-                <c:pt idx="1">
-                  <c:v>CARE 21%</c:v>
-                </c:pt>
-                <c:pt idx="2">
-                  <c:v>ICRA 14%</c:v>
-                </c:pt>
-                <c:pt idx="3">
-                  <c:v>India Ratings 12%</c:v>
-                </c:pt>
-                <c:pt idx="4">
-                  <c:v>Infomerics 5%</c:v>
-                </c:pt>
-                <c:pt idx="5">
-                  <c:v>Acuite 3%</c:v>
-                </c:pt>
-                <c:pt idx="6">
-                  <c:v>Others 1%</c:v>
-                </c:pt>
-              </c:strCache>
-            </c:strRef>
-          </c:cat>
-          <c:val>
-            <c:numRef>
-              <c:f>Sheet1!$B$2:$B$8</c:f>
-              <c:numCache>
-                <c:ptCount val="7"/>
-                <c:pt idx="0">
-                  <c:v>44</c:v>
-                </c:pt>
-                <c:pt idx="1">
-                  <c:v>21</c:v>
-                </c:pt>
-                <c:pt idx="2">
-                  <c:v>14</c:v>
-                </c:pt>
-                <c:pt idx="3">
-                  <c:v>12</c:v>
-                </c:pt>
-                <c:pt idx="4">
-                  <c:v>5</c:v>
-                </c:pt>
-                <c:pt idx="5">
-                  <c:v>3</c:v>
-                </c:pt>
-                <c:pt idx="6">
-                  <c:v>1</c:v>
-                </c:pt>
-              </c:numCache>
-            </c:numRef>
-          </c:val>
-        </c:ser>
-        <c:firstSliceAng val="0"/>
-        <c:holeSize val="50"/>
-      </c:doughnutChart>
-      <c:spPr>
-        <a:noFill/>
-        <a:ln>
-          <a:noFill/>
-        </a:ln>
-        <a:effectLst/>
-      </c:spPr>
-    </c:plotArea>
-    <c:legend>
-      <c:legendPos val="r"/>
-      <c:overlay val="0"/>
-      <c:txPr>
-        <a:bodyPr/>
-        <a:lstStyle/>
-        <a:p>
-          <a:pPr>
-            <a:defRPr sz="1050">
-              <a:solidFill>
-                <a:srgbClr val="2B3F52"/>
-              </a:solidFill>
-              <a:latin typeface="Calibri"/>
-              <a:cs typeface="Calibri"/>
-            </a:defRPr>
-          </a:pPr>
-          <a:endParaRPr lang="en-US"/>
-        </a:p>
-      </c:txPr>
-    </c:legend>
     <c:plotVisOnly val="1"/>
     <c:dispBlanksAs val="span"/>
   </c:chart>
@@ -11325,7 +10913,7 @@
                 <a:ea typeface="Calibri" pitchFamily="34" charset="-122"/>
                 <a:cs typeface="Calibri" pitchFamily="34" charset="-120"/>
               </a:rPr>
-              <a:t>MARKET OPPORTUNITY</a:t>
+              <a:t>DOABILITY</a:t>
             </a:r>
             <a:endParaRPr lang="en-US" sz="1100" dirty="0"/>
           </a:p>
@@ -11364,7 +10952,7 @@
                 <a:ea typeface="Cambria" pitchFamily="34" charset="-122"/>
                 <a:cs typeface="Cambria" pitchFamily="34" charset="-120"/>
               </a:rPr>
-              <a:t>The CRA market pie, and where ACER concentrates</a:t>
+              <a:t>Rating Rs 1,600 Cr a month is a small slice of a vast market</a:t>
             </a:r>
             <a:endParaRPr lang="en-US" sz="2600" dirty="0"/>
           </a:p>
@@ -11378,8 +10966,8 @@
         </p:nvSpPr>
         <p:spPr>
           <a:xfrm>
-            <a:off x="640080" y="1463040"/>
-            <a:ext cx="5852160" cy="274320"/>
+            <a:off x="640080" y="1417320"/>
+            <a:ext cx="10972800" cy="457200"/>
           </a:xfrm>
           <a:prstGeom prst="rect">
             <a:avLst/>
@@ -11395,85 +10983,30 @@
               <a:buNone/>
             </a:pPr>
             <a:r>
-              <a:rPr lang="en-US" sz="1200" b="1" dirty="0">
-                <a:solidFill>
-                  <a:srgbClr val="2B3F52"/>
+              <a:rPr lang="en-US" sz="1300" dirty="0">
+                <a:solidFill>
+                  <a:srgbClr val="5B6B7B"/>
                 </a:solidFill>
                 <a:latin typeface="Calibri" pitchFamily="34" charset="0"/>
                 <a:ea typeface="Calibri" pitchFamily="34" charset="-122"/>
                 <a:cs typeface="Calibri" pitchFamily="34" charset="-120"/>
               </a:rPr>
-              <a:t>Share of the ~Rs 2,000 Cr rating industry, by agency</a:t>
-            </a:r>
-            <a:endParaRPr lang="en-US" sz="1200" dirty="0"/>
-          </a:p>
-        </p:txBody>
-      </p:sp>
-      <p:graphicFrame>
-        <p:nvGraphicFramePr>
-          <p:cNvPr id="5" name="Chart 0" descr=""/>
-          <p:cNvGraphicFramePr/>
-          <p:nvPr/>
-        </p:nvGraphicFramePr>
-        <p:xfrm>
-          <a:off x="548640" y="1783080"/>
-          <a:ext cx="5943600" cy="3611880"/>
-        </p:xfrm>
-        <a:graphic xmlns:a="http://schemas.openxmlformats.org/drawingml/2006/main">
-          <a:graphicData uri="http://schemas.openxmlformats.org/drawingml/2006/chart">
-            <c:chart xmlns:c="http://schemas.openxmlformats.org/drawingml/2006/chart" r:id="rId1"/>
-          </a:graphicData>
-        </a:graphic>
-      </p:graphicFrame>
-      <p:sp>
-        <p:nvSpPr>
-          <p:cNvPr id="6" name="Text 3"/>
-          <p:cNvSpPr/>
-          <p:nvPr/>
-        </p:nvSpPr>
-        <p:spPr>
-          <a:xfrm>
-            <a:off x="6675120" y="1463040"/>
-            <a:ext cx="4937760" cy="274320"/>
-          </a:xfrm>
-          <a:prstGeom prst="rect">
-            <a:avLst/>
-          </a:prstGeom>
-          <a:noFill/>
-          <a:ln/>
-        </p:spPr>
-        <p:txBody>
-          <a:bodyPr wrap="square" rtlCol="0" anchor="ctr"/>
-          <a:lstStyle/>
-          <a:p>
-            <a:pPr indent="0" marL="0">
-              <a:buNone/>
-            </a:pPr>
-            <a:r>
-              <a:rPr lang="en-US" sz="1200" b="1" dirty="0">
-                <a:solidFill>
-                  <a:srgbClr val="2B3F52"/>
-                </a:solidFill>
-                <a:latin typeface="Calibri" pitchFamily="34" charset="0"/>
-                <a:ea typeface="Calibri" pitchFamily="34" charset="-122"/>
-                <a:cs typeface="Calibri" pitchFamily="34" charset="-120"/>
-              </a:rPr>
-              <a:t>Where ACER concentrates</a:t>
-            </a:r>
-            <a:endParaRPr lang="en-US" sz="1200" dirty="0"/>
-          </a:p>
-        </p:txBody>
-      </p:sp>
-      <p:sp>
-        <p:nvSpPr>
-          <p:cNvPr id="7" name="Shape 4"/>
-          <p:cNvSpPr/>
-          <p:nvPr/>
-        </p:nvSpPr>
-        <p:spPr>
-          <a:xfrm>
-            <a:off x="6675120" y="1783080"/>
-            <a:ext cx="4937760" cy="868680"/>
+              <a:t>ACER target: Rs 1,600 Cr rated per month, Rs 19,200 Cr per year, about 192 mandates. Set against the market and peer scale, it is a small, credible slice.</a:t>
+            </a:r>
+            <a:endParaRPr lang="en-US" sz="1300" dirty="0"/>
+          </a:p>
+        </p:txBody>
+      </p:sp>
+      <p:sp>
+        <p:nvSpPr>
+          <p:cNvPr id="5" name="Shape 3"/>
+          <p:cNvSpPr/>
+          <p:nvPr/>
+        </p:nvSpPr>
+        <p:spPr>
+          <a:xfrm>
+            <a:off x="640080" y="1965960"/>
+            <a:ext cx="2606040" cy="1371600"/>
           </a:xfrm>
           <a:prstGeom prst="rect">
             <a:avLst/>
@@ -11491,14 +11024,14 @@
       </p:sp>
       <p:sp>
         <p:nvSpPr>
-          <p:cNvPr id="8" name="Text 5"/>
-          <p:cNvSpPr/>
-          <p:nvPr/>
-        </p:nvSpPr>
-        <p:spPr>
-          <a:xfrm>
-            <a:off x="6839712" y="1920240"/>
-            <a:ext cx="4608576" cy="274320"/>
+          <p:cNvPr id="6" name="Text 4"/>
+          <p:cNvSpPr/>
+          <p:nvPr/>
+        </p:nvSpPr>
+        <p:spPr>
+          <a:xfrm>
+            <a:off x="804672" y="2103120"/>
+            <a:ext cx="2276856" cy="274320"/>
           </a:xfrm>
           <a:prstGeom prst="rect">
             <a:avLst/>
@@ -11522,7 +11055,7 @@
                 <a:ea typeface="Calibri" pitchFamily="34" charset="-122"/>
                 <a:cs typeface="Calibri" pitchFamily="34" charset="-120"/>
               </a:rPr>
-              <a:t>TAM  ·  whole rating industry</a:t>
+              <a:t>of India bank credit</a:t>
             </a:r>
             <a:endParaRPr lang="en-US" sz="1050" dirty="0"/>
           </a:p>
@@ -11530,14 +11063,14 @@
       </p:sp>
       <p:sp>
         <p:nvSpPr>
-          <p:cNvPr id="9" name="Text 6"/>
-          <p:cNvSpPr/>
-          <p:nvPr/>
-        </p:nvSpPr>
-        <p:spPr>
-          <a:xfrm>
-            <a:off x="6839712" y="2167128"/>
-            <a:ext cx="4608576" cy="457200"/>
+          <p:cNvPr id="7" name="Text 5"/>
+          <p:cNvSpPr/>
+          <p:nvPr/>
+        </p:nvSpPr>
+        <p:spPr>
+          <a:xfrm>
+            <a:off x="804672" y="2350008"/>
+            <a:ext cx="2276856" cy="457200"/>
           </a:xfrm>
           <a:prstGeom prst="rect">
             <a:avLst/>
@@ -11555,13 +11088,13 @@
             <a:r>
               <a:rPr lang="en-US" sz="2200" b="1" dirty="0">
                 <a:solidFill>
-                  <a:srgbClr val="0A1F33"/>
+                  <a:srgbClr val="0F766E"/>
                 </a:solidFill>
                 <a:latin typeface="Cambria" pitchFamily="34" charset="0"/>
                 <a:ea typeface="Cambria" pitchFamily="34" charset="-122"/>
                 <a:cs typeface="Cambria" pitchFamily="34" charset="-120"/>
               </a:rPr>
-              <a:t>Rs 2,000 Cr</a:t>
+              <a:t>~0.27%</a:t>
             </a:r>
             <a:endParaRPr lang="en-US" sz="2200" dirty="0"/>
           </a:p>
@@ -11569,14 +11102,53 @@
       </p:sp>
       <p:sp>
         <p:nvSpPr>
-          <p:cNvPr id="10" name="Shape 7"/>
-          <p:cNvSpPr/>
-          <p:nvPr/>
-        </p:nvSpPr>
-        <p:spPr>
-          <a:xfrm>
-            <a:off x="6675120" y="2743200"/>
-            <a:ext cx="4937760" cy="868680"/>
+          <p:cNvPr id="8" name="Text 6"/>
+          <p:cNvSpPr/>
+          <p:nvPr/>
+        </p:nvSpPr>
+        <p:spPr>
+          <a:xfrm>
+            <a:off x="804672" y="2825496"/>
+            <a:ext cx="2276856" cy="365760"/>
+          </a:xfrm>
+          <a:prstGeom prst="rect">
+            <a:avLst/>
+          </a:prstGeom>
+          <a:noFill/>
+          <a:ln/>
+        </p:spPr>
+        <p:txBody>
+          <a:bodyPr wrap="square" rtlCol="0" anchor="ctr"/>
+          <a:lstStyle/>
+          <a:p>
+            <a:pPr indent="0" marL="0">
+              <a:buNone/>
+            </a:pPr>
+            <a:r>
+              <a:rPr lang="en-US" sz="900" dirty="0">
+                <a:solidFill>
+                  <a:srgbClr val="9AA7B4"/>
+                </a:solidFill>
+                <a:latin typeface="Calibri" pitchFamily="34" charset="0"/>
+                <a:ea typeface="Calibri" pitchFamily="34" charset="-122"/>
+                <a:cs typeface="Calibri" pitchFamily="34" charset="-120"/>
+              </a:rPr>
+              <a:t>~Rs 70 lakh cr outstanding</a:t>
+            </a:r>
+            <a:endParaRPr lang="en-US" sz="900" dirty="0"/>
+          </a:p>
+        </p:txBody>
+      </p:sp>
+      <p:sp>
+        <p:nvSpPr>
+          <p:cNvPr id="9" name="Shape 7"/>
+          <p:cNvSpPr/>
+          <p:nvPr/>
+        </p:nvSpPr>
+        <p:spPr>
+          <a:xfrm>
+            <a:off x="3383280" y="1965960"/>
+            <a:ext cx="2606040" cy="1371600"/>
           </a:xfrm>
           <a:prstGeom prst="rect">
             <a:avLst/>
@@ -11594,14 +11166,14 @@
       </p:sp>
       <p:sp>
         <p:nvSpPr>
-          <p:cNvPr id="11" name="Text 8"/>
-          <p:cNvSpPr/>
-          <p:nvPr/>
-        </p:nvSpPr>
-        <p:spPr>
-          <a:xfrm>
-            <a:off x="6839712" y="2880360"/>
-            <a:ext cx="4608576" cy="274320"/>
+          <p:cNvPr id="10" name="Text 8"/>
+          <p:cNvSpPr/>
+          <p:nvPr/>
+        </p:nvSpPr>
+        <p:spPr>
+          <a:xfrm>
+            <a:off x="3547872" y="2103120"/>
+            <a:ext cx="2276856" cy="274320"/>
           </a:xfrm>
           <a:prstGeom prst="rect">
             <a:avLst/>
@@ -11625,7 +11197,7 @@
                 <a:ea typeface="Calibri" pitchFamily="34" charset="-122"/>
                 <a:cs typeface="Calibri" pitchFamily="34" charset="-120"/>
               </a:rPr>
-              <a:t>SAM  ·  Rs 100 Cr+ BLR segment</a:t>
+              <a:t>of annual bond issuance</a:t>
             </a:r>
             <a:endParaRPr lang="en-US" sz="1050" dirty="0"/>
           </a:p>
@@ -11633,14 +11205,14 @@
       </p:sp>
       <p:sp>
         <p:nvSpPr>
-          <p:cNvPr id="12" name="Text 9"/>
-          <p:cNvSpPr/>
-          <p:nvPr/>
-        </p:nvSpPr>
-        <p:spPr>
-          <a:xfrm>
-            <a:off x="6839712" y="3127248"/>
-            <a:ext cx="4608576" cy="457200"/>
+          <p:cNvPr id="11" name="Text 9"/>
+          <p:cNvSpPr/>
+          <p:nvPr/>
+        </p:nvSpPr>
+        <p:spPr>
+          <a:xfrm>
+            <a:off x="3547872" y="2350008"/>
+            <a:ext cx="2276856" cy="457200"/>
           </a:xfrm>
           <a:prstGeom prst="rect">
             <a:avLst/>
@@ -11658,13 +11230,13 @@
             <a:r>
               <a:rPr lang="en-US" sz="2200" b="1" dirty="0">
                 <a:solidFill>
-                  <a:srgbClr val="1E4E79"/>
+                  <a:srgbClr val="0F766E"/>
                 </a:solidFill>
                 <a:latin typeface="Cambria" pitchFamily="34" charset="0"/>
                 <a:ea typeface="Cambria" pitchFamily="34" charset="-122"/>
                 <a:cs typeface="Cambria" pitchFamily="34" charset="-120"/>
               </a:rPr>
-              <a:t>Rs 500 Cr</a:t>
+              <a:t>~1.9%</a:t>
             </a:r>
             <a:endParaRPr lang="en-US" sz="2200" dirty="0"/>
           </a:p>
@@ -11672,14 +11244,14 @@
       </p:sp>
       <p:sp>
         <p:nvSpPr>
-          <p:cNvPr id="13" name="Text 10"/>
-          <p:cNvSpPr/>
-          <p:nvPr/>
-        </p:nvSpPr>
-        <p:spPr>
-          <a:xfrm>
-            <a:off x="6839712" y="3602736"/>
-            <a:ext cx="4608576" cy="365760"/>
+          <p:cNvPr id="12" name="Text 10"/>
+          <p:cNvSpPr/>
+          <p:nvPr/>
+        </p:nvSpPr>
+        <p:spPr>
+          <a:xfrm>
+            <a:off x="3547872" y="2825496"/>
+            <a:ext cx="2276856" cy="365760"/>
           </a:xfrm>
           <a:prstGeom prst="rect">
             <a:avLst/>
@@ -11703,7 +11275,7 @@
                 <a:ea typeface="Calibri" pitchFamily="34" charset="-122"/>
                 <a:cs typeface="Calibri" pitchFamily="34" charset="-120"/>
               </a:rPr>
-              <a:t>the slice we target</a:t>
+              <a:t>~Rs 10 lakh cr in FY25</a:t>
             </a:r>
             <a:endParaRPr lang="en-US" sz="900" dirty="0"/>
           </a:p>
@@ -11711,14 +11283,14 @@
       </p:sp>
       <p:sp>
         <p:nvSpPr>
-          <p:cNvPr id="14" name="Shape 11"/>
-          <p:cNvSpPr/>
-          <p:nvPr/>
-        </p:nvSpPr>
-        <p:spPr>
-          <a:xfrm>
-            <a:off x="6675120" y="3703320"/>
-            <a:ext cx="4937760" cy="868680"/>
+          <p:cNvPr id="13" name="Shape 11"/>
+          <p:cNvSpPr/>
+          <p:nvPr/>
+        </p:nvSpPr>
+        <p:spPr>
+          <a:xfrm>
+            <a:off x="6126480" y="1965960"/>
+            <a:ext cx="2606040" cy="1371600"/>
           </a:xfrm>
           <a:prstGeom prst="rect">
             <a:avLst/>
@@ -11736,14 +11308,14 @@
       </p:sp>
       <p:sp>
         <p:nvSpPr>
-          <p:cNvPr id="15" name="Text 12"/>
-          <p:cNvSpPr/>
-          <p:nvPr/>
-        </p:nvSpPr>
-        <p:spPr>
-          <a:xfrm>
-            <a:off x="6839712" y="3840480"/>
-            <a:ext cx="4608576" cy="274320"/>
+          <p:cNvPr id="14" name="Text 12"/>
+          <p:cNvSpPr/>
+          <p:nvPr/>
+        </p:nvSpPr>
+        <p:spPr>
+          <a:xfrm>
+            <a:off x="6291072" y="2103120"/>
+            <a:ext cx="2276856" cy="274320"/>
           </a:xfrm>
           <a:prstGeom prst="rect">
             <a:avLst/>
@@ -11767,7 +11339,7 @@
                 <a:ea typeface="Calibri" pitchFamily="34" charset="-122"/>
                 <a:cs typeface="Calibri" pitchFamily="34" charset="-120"/>
               </a:rPr>
-              <a:t>SOM  ·  ACER by FY28</a:t>
+              <a:t>of Brickwork lifetime rated</a:t>
             </a:r>
             <a:endParaRPr lang="en-US" sz="1050" dirty="0"/>
           </a:p>
@@ -11775,14 +11347,14 @@
       </p:sp>
       <p:sp>
         <p:nvSpPr>
-          <p:cNvPr id="16" name="Text 13"/>
-          <p:cNvSpPr/>
-          <p:nvPr/>
-        </p:nvSpPr>
-        <p:spPr>
-          <a:xfrm>
-            <a:off x="6839712" y="4087368"/>
-            <a:ext cx="4608576" cy="457200"/>
+          <p:cNvPr id="15" name="Text 13"/>
+          <p:cNvSpPr/>
+          <p:nvPr/>
+        </p:nvSpPr>
+        <p:spPr>
+          <a:xfrm>
+            <a:off x="6291072" y="2350008"/>
+            <a:ext cx="2276856" cy="457200"/>
           </a:xfrm>
           <a:prstGeom prst="rect">
             <a:avLst/>
@@ -11806,7 +11378,7 @@
                 <a:ea typeface="Cambria" pitchFamily="34" charset="-122"/>
                 <a:cs typeface="Cambria" pitchFamily="34" charset="-120"/>
               </a:rPr>
-              <a:t>Rs 8 Cr</a:t>
+              <a:t>~1%</a:t>
             </a:r>
             <a:endParaRPr lang="en-US" sz="2200" dirty="0"/>
           </a:p>
@@ -11814,14 +11386,14 @@
       </p:sp>
       <p:sp>
         <p:nvSpPr>
-          <p:cNvPr id="17" name="Text 14"/>
-          <p:cNvSpPr/>
-          <p:nvPr/>
-        </p:nvSpPr>
-        <p:spPr>
-          <a:xfrm>
-            <a:off x="6839712" y="4562856"/>
-            <a:ext cx="4608576" cy="365760"/>
+          <p:cNvPr id="16" name="Text 14"/>
+          <p:cNvSpPr/>
+          <p:nvPr/>
+        </p:nvSpPr>
+        <p:spPr>
+          <a:xfrm>
+            <a:off x="6291072" y="2825496"/>
+            <a:ext cx="2276856" cy="365760"/>
           </a:xfrm>
           <a:prstGeom prst="rect">
             <a:avLst/>
@@ -11845,7 +11417,7 @@
                 <a:ea typeface="Calibri" pitchFamily="34" charset="-122"/>
                 <a:cs typeface="Calibri" pitchFamily="34" charset="-120"/>
               </a:rPr>
-              <a:t>about 0.4% of the pie</a:t>
+              <a:t>Rs 19.18 lakh cr, 11,560+ entities</a:t>
             </a:r>
             <a:endParaRPr lang="en-US" sz="900" dirty="0"/>
           </a:p>
@@ -11853,112 +11425,21 @@
       </p:sp>
       <p:sp>
         <p:nvSpPr>
-          <p:cNvPr id="18" name="Shape 15"/>
-          <p:cNvSpPr/>
-          <p:nvPr/>
-        </p:nvSpPr>
-        <p:spPr>
-          <a:xfrm>
-            <a:off x="640080" y="5074920"/>
-            <a:ext cx="10911535" cy="731520"/>
+          <p:cNvPr id="17" name="Shape 15"/>
+          <p:cNvSpPr/>
+          <p:nvPr/>
+        </p:nvSpPr>
+        <p:spPr>
+          <a:xfrm>
+            <a:off x="8869680" y="1965960"/>
+            <a:ext cx="2606040" cy="1371600"/>
           </a:xfrm>
           <a:prstGeom prst="rect">
             <a:avLst/>
           </a:prstGeom>
           <a:solidFill>
-            <a:srgbClr val="EEF4F3"/>
+            <a:srgbClr val="F6F8FA"/>
           </a:solidFill>
-          <a:ln/>
-        </p:spPr>
-      </p:sp>
-      <p:sp>
-        <p:nvSpPr>
-          <p:cNvPr id="19" name="Shape 16"/>
-          <p:cNvSpPr/>
-          <p:nvPr/>
-        </p:nvSpPr>
-        <p:spPr>
-          <a:xfrm>
-            <a:off x="640080" y="5074920"/>
-            <a:ext cx="82296" cy="731520"/>
-          </a:xfrm>
-          <a:prstGeom prst="rect">
-            <a:avLst/>
-          </a:prstGeom>
-          <a:solidFill>
-            <a:srgbClr val="0F766E"/>
-          </a:solidFill>
-          <a:ln/>
-        </p:spPr>
-      </p:sp>
-      <p:sp>
-        <p:nvSpPr>
-          <p:cNvPr id="20" name="Text 17"/>
-          <p:cNvSpPr/>
-          <p:nvPr/>
-        </p:nvSpPr>
-        <p:spPr>
-          <a:xfrm>
-            <a:off x="896112" y="5074920"/>
-            <a:ext cx="10454335" cy="731520"/>
-          </a:xfrm>
-          <a:prstGeom prst="rect">
-            <a:avLst/>
-          </a:prstGeom>
-          <a:noFill/>
-          <a:ln/>
-        </p:spPr>
-        <p:txBody>
-          <a:bodyPr wrap="square" rtlCol="0" anchor="ctr"/>
-          <a:lstStyle/>
-          <a:p>
-            <a:pPr indent="0" marL="0">
-              <a:buNone/>
-            </a:pPr>
-            <a:r>
-              <a:rPr lang="en-US" sz="1000" b="1" spc="100" kern="0" dirty="0">
-                <a:solidFill>
-                  <a:srgbClr val="0F766E"/>
-                </a:solidFill>
-                <a:latin typeface="Calibri" pitchFamily="34" charset="0"/>
-                <a:ea typeface="Calibri" pitchFamily="34" charset="-122"/>
-                <a:cs typeface="Calibri" pitchFamily="34" charset="-120"/>
-              </a:rPr>
-              <a:t>THE TAKEAWAY   </a:t>
-            </a:r>
-            <a:pPr indent="0" marL="0">
-              <a:buNone/>
-            </a:pPr>
-            <a:r>
-              <a:rPr lang="en-US" sz="1300" b="1" dirty="0">
-                <a:solidFill>
-                  <a:srgbClr val="0A1F33"/>
-                </a:solidFill>
-                <a:latin typeface="Calibri" pitchFamily="34" charset="0"/>
-                <a:ea typeface="Calibri" pitchFamily="34" charset="-122"/>
-                <a:cs typeface="Calibri" pitchFamily="34" charset="-120"/>
-              </a:rPr>
-              <a:t>ACER concentrates on the Rs 100 Cr plus bank loan rating segment; the FY28 target of Rs 8 Cr is about 0.4% of the pie, won from a standing start.</a:t>
-            </a:r>
-            <a:endParaRPr lang="en-US" sz="1000" dirty="0"/>
-          </a:p>
-        </p:txBody>
-      </p:sp>
-      <p:sp>
-        <p:nvSpPr>
-          <p:cNvPr id="21" name="Shape 18"/>
-          <p:cNvSpPr/>
-          <p:nvPr/>
-        </p:nvSpPr>
-        <p:spPr>
-          <a:xfrm>
-            <a:off x="640080" y="6437376"/>
-            <a:ext cx="10911535" cy="0"/>
-          </a:xfrm>
-          <a:prstGeom prst="line">
-            <a:avLst/>
-          </a:prstGeom>
-          <a:noFill/>
           <a:ln w="12700">
             <a:solidFill>
               <a:srgbClr val="E6E9EE"/>
@@ -11969,38 +11450,394 @@
       </p:sp>
       <p:sp>
         <p:nvSpPr>
-          <p:cNvPr id="22" name="Text 19"/>
-          <p:cNvSpPr/>
-          <p:nvPr/>
-        </p:nvSpPr>
-        <p:spPr>
-          <a:xfrm>
-            <a:off x="640080" y="6483096"/>
-            <a:ext cx="9509760" cy="292608"/>
-          </a:xfrm>
-          <a:prstGeom prst="rect">
-            <a:avLst/>
-          </a:prstGeom>
-          <a:noFill/>
-          <a:ln/>
-        </p:spPr>
-        <p:txBody>
-          <a:bodyPr wrap="square" rtlCol="0" anchor="t"/>
+          <p:cNvPr id="18" name="Text 16"/>
+          <p:cNvSpPr/>
+          <p:nvPr/>
+        </p:nvSpPr>
+        <p:spPr>
+          <a:xfrm>
+            <a:off x="9034272" y="2103120"/>
+            <a:ext cx="2276856" cy="274320"/>
+          </a:xfrm>
+          <a:prstGeom prst="rect">
+            <a:avLst/>
+          </a:prstGeom>
+          <a:noFill/>
+          <a:ln/>
+        </p:spPr>
+        <p:txBody>
+          <a:bodyPr wrap="square" rtlCol="0" anchor="ctr"/>
           <a:lstStyle/>
           <a:p>
             <a:pPr indent="0" marL="0">
               <a:buNone/>
             </a:pPr>
             <a:r>
-              <a:rPr lang="en-US" sz="850" dirty="0">
-                <a:solidFill>
-                  <a:srgbClr val="9AA7B4"/>
+              <a:rPr lang="en-US" sz="1050" dirty="0">
+                <a:solidFill>
+                  <a:srgbClr val="5B6B7B"/>
                 </a:solidFill>
                 <a:latin typeface="Calibri" pitchFamily="34" charset="0"/>
                 <a:ea typeface="Calibri" pitchFamily="34" charset="-122"/>
                 <a:cs typeface="Calibri" pitchFamily="34" charset="-120"/>
               </a:rPr>
-              <a:t>Source: shares estimated from official rating revenues [3][4][5][6][7][8]; industry ~Rs 2,000 Cr is an analyst estimate. ACER [1][2].</a:t>
+              <a:t>mandates a year</a:t>
+            </a:r>
+            <a:endParaRPr lang="en-US" sz="1050" dirty="0"/>
+          </a:p>
+        </p:txBody>
+      </p:sp>
+      <p:sp>
+        <p:nvSpPr>
+          <p:cNvPr id="19" name="Text 17"/>
+          <p:cNvSpPr/>
+          <p:nvPr/>
+        </p:nvSpPr>
+        <p:spPr>
+          <a:xfrm>
+            <a:off x="9034272" y="2350008"/>
+            <a:ext cx="2276856" cy="457200"/>
+          </a:xfrm>
+          <a:prstGeom prst="rect">
+            <a:avLst/>
+          </a:prstGeom>
+          <a:noFill/>
+          <a:ln/>
+        </p:spPr>
+        <p:txBody>
+          <a:bodyPr wrap="square" rtlCol="0" anchor="ctr"/>
+          <a:lstStyle/>
+          <a:p>
+            <a:pPr indent="0" marL="0">
+              <a:buNone/>
+            </a:pPr>
+            <a:r>
+              <a:rPr lang="en-US" sz="2200" b="1" dirty="0">
+                <a:solidFill>
+                  <a:srgbClr val="0A1F33"/>
+                </a:solidFill>
+                <a:latin typeface="Cambria" pitchFamily="34" charset="0"/>
+                <a:ea typeface="Cambria" pitchFamily="34" charset="-122"/>
+                <a:cs typeface="Cambria" pitchFamily="34" charset="-120"/>
+              </a:rPr>
+              <a:t>192</a:t>
+            </a:r>
+            <a:endParaRPr lang="en-US" sz="2200" dirty="0"/>
+          </a:p>
+        </p:txBody>
+      </p:sp>
+      <p:sp>
+        <p:nvSpPr>
+          <p:cNvPr id="20" name="Text 18"/>
+          <p:cNvSpPr/>
+          <p:nvPr/>
+        </p:nvSpPr>
+        <p:spPr>
+          <a:xfrm>
+            <a:off x="9034272" y="2825496"/>
+            <a:ext cx="2276856" cy="365760"/>
+          </a:xfrm>
+          <a:prstGeom prst="rect">
+            <a:avLst/>
+          </a:prstGeom>
+          <a:noFill/>
+          <a:ln/>
+        </p:spPr>
+        <p:txBody>
+          <a:bodyPr wrap="square" rtlCol="0" anchor="ctr"/>
+          <a:lstStyle/>
+          <a:p>
+            <a:pPr indent="0" marL="0">
+              <a:buNone/>
+            </a:pPr>
+            <a:r>
+              <a:rPr lang="en-US" sz="900" dirty="0">
+                <a:solidFill>
+                  <a:srgbClr val="9AA7B4"/>
+                </a:solidFill>
+                <a:latin typeface="Calibri" pitchFamily="34" charset="0"/>
+                <a:ea typeface="Calibri" pitchFamily="34" charset="-122"/>
+                <a:cs typeface="Calibri" pitchFamily="34" charset="-120"/>
+              </a:rPr>
+              <a:t>vs CRISIL ~19,500 rated issuers</a:t>
+            </a:r>
+            <a:endParaRPr lang="en-US" sz="900" dirty="0"/>
+          </a:p>
+        </p:txBody>
+      </p:sp>
+      <p:sp>
+        <p:nvSpPr>
+          <p:cNvPr id="21" name="Shape 19"/>
+          <p:cNvSpPr/>
+          <p:nvPr/>
+        </p:nvSpPr>
+        <p:spPr>
+          <a:xfrm>
+            <a:off x="640080" y="3749040"/>
+            <a:ext cx="10972800" cy="502920"/>
+          </a:xfrm>
+          <a:prstGeom prst="rect">
+            <a:avLst/>
+          </a:prstGeom>
+          <a:solidFill>
+            <a:srgbClr val="F6F8FA"/>
+          </a:solidFill>
+          <a:ln w="12700">
+            <a:solidFill>
+              <a:srgbClr val="E6E9EE"/>
+            </a:solidFill>
+            <a:prstDash val="solid"/>
+          </a:ln>
+        </p:spPr>
+      </p:sp>
+      <p:sp>
+        <p:nvSpPr>
+          <p:cNvPr id="22" name="Shape 20"/>
+          <p:cNvSpPr/>
+          <p:nvPr/>
+        </p:nvSpPr>
+        <p:spPr>
+          <a:xfrm>
+            <a:off x="640080" y="3749040"/>
+            <a:ext cx="91440" cy="502920"/>
+          </a:xfrm>
+          <a:prstGeom prst="rect">
+            <a:avLst/>
+          </a:prstGeom>
+          <a:solidFill>
+            <a:srgbClr val="0F766E"/>
+          </a:solidFill>
+          <a:ln/>
+        </p:spPr>
+      </p:sp>
+      <p:sp>
+        <p:nvSpPr>
+          <p:cNvPr id="23" name="Text 21"/>
+          <p:cNvSpPr/>
+          <p:nvPr/>
+        </p:nvSpPr>
+        <p:spPr>
+          <a:xfrm>
+            <a:off x="914400" y="3749040"/>
+            <a:ext cx="8229600" cy="502920"/>
+          </a:xfrm>
+          <a:prstGeom prst="rect">
+            <a:avLst/>
+          </a:prstGeom>
+          <a:noFill/>
+          <a:ln/>
+        </p:spPr>
+        <p:txBody>
+          <a:bodyPr wrap="square" rtlCol="0" anchor="ctr"/>
+          <a:lstStyle/>
+          <a:p>
+            <a:pPr indent="0" marL="0">
+              <a:buNone/>
+            </a:pPr>
+            <a:r>
+              <a:rPr lang="en-US" sz="1150" dirty="0">
+                <a:solidFill>
+                  <a:srgbClr val="5B6B7B"/>
+                </a:solidFill>
+                <a:latin typeface="Calibri" pitchFamily="34" charset="0"/>
+                <a:ea typeface="Calibri" pitchFamily="34" charset="-122"/>
+                <a:cs typeface="Calibri" pitchFamily="34" charset="-120"/>
+              </a:rPr>
+              <a:t>Rest of India's ~Rs 70 lakh crore of outstanding bank credit</a:t>
+            </a:r>
+            <a:endParaRPr lang="en-US" sz="1150" dirty="0"/>
+          </a:p>
+        </p:txBody>
+      </p:sp>
+      <p:sp>
+        <p:nvSpPr>
+          <p:cNvPr id="24" name="Text 22"/>
+          <p:cNvSpPr/>
+          <p:nvPr/>
+        </p:nvSpPr>
+        <p:spPr>
+          <a:xfrm>
+            <a:off x="640080" y="4315968"/>
+            <a:ext cx="10972800" cy="320040"/>
+          </a:xfrm>
+          <a:prstGeom prst="rect">
+            <a:avLst/>
+          </a:prstGeom>
+          <a:noFill/>
+          <a:ln/>
+        </p:spPr>
+        <p:txBody>
+          <a:bodyPr wrap="square" rtlCol="0" anchor="ctr"/>
+          <a:lstStyle/>
+          <a:p>
+            <a:pPr indent="0" marL="0">
+              <a:buNone/>
+            </a:pPr>
+            <a:r>
+              <a:rPr lang="en-US" sz="1150" b="1" dirty="0">
+                <a:solidFill>
+                  <a:srgbClr val="0F766E"/>
+                </a:solidFill>
+                <a:latin typeface="Calibri" pitchFamily="34" charset="0"/>
+                <a:ea typeface="Calibri" pitchFamily="34" charset="-122"/>
+                <a:cs typeface="Calibri" pitchFamily="34" charset="-120"/>
+              </a:rPr>
+              <a:t>The teal sliver is ACER's entire Rs 19,200 Cr yearly target, about 0.27% of outstanding bank credit.</a:t>
+            </a:r>
+            <a:endParaRPr lang="en-US" sz="1150" dirty="0"/>
+          </a:p>
+        </p:txBody>
+      </p:sp>
+      <p:sp>
+        <p:nvSpPr>
+          <p:cNvPr id="25" name="Shape 23"/>
+          <p:cNvSpPr/>
+          <p:nvPr/>
+        </p:nvSpPr>
+        <p:spPr>
+          <a:xfrm>
+            <a:off x="640080" y="4937760"/>
+            <a:ext cx="10911535" cy="731520"/>
+          </a:xfrm>
+          <a:prstGeom prst="rect">
+            <a:avLst/>
+          </a:prstGeom>
+          <a:solidFill>
+            <a:srgbClr val="EEF4F3"/>
+          </a:solidFill>
+          <a:ln/>
+        </p:spPr>
+      </p:sp>
+      <p:sp>
+        <p:nvSpPr>
+          <p:cNvPr id="26" name="Shape 24"/>
+          <p:cNvSpPr/>
+          <p:nvPr/>
+        </p:nvSpPr>
+        <p:spPr>
+          <a:xfrm>
+            <a:off x="640080" y="4937760"/>
+            <a:ext cx="82296" cy="731520"/>
+          </a:xfrm>
+          <a:prstGeom prst="rect">
+            <a:avLst/>
+          </a:prstGeom>
+          <a:solidFill>
+            <a:srgbClr val="0F766E"/>
+          </a:solidFill>
+          <a:ln/>
+        </p:spPr>
+      </p:sp>
+      <p:sp>
+        <p:nvSpPr>
+          <p:cNvPr id="27" name="Text 25"/>
+          <p:cNvSpPr/>
+          <p:nvPr/>
+        </p:nvSpPr>
+        <p:spPr>
+          <a:xfrm>
+            <a:off x="896112" y="4937760"/>
+            <a:ext cx="10454335" cy="731520"/>
+          </a:xfrm>
+          <a:prstGeom prst="rect">
+            <a:avLst/>
+          </a:prstGeom>
+          <a:noFill/>
+          <a:ln/>
+        </p:spPr>
+        <p:txBody>
+          <a:bodyPr wrap="square" rtlCol="0" anchor="ctr"/>
+          <a:lstStyle/>
+          <a:p>
+            <a:pPr indent="0" marL="0">
+              <a:buNone/>
+            </a:pPr>
+            <a:r>
+              <a:rPr lang="en-US" sz="1000" b="1" spc="100" kern="0" dirty="0">
+                <a:solidFill>
+                  <a:srgbClr val="0F766E"/>
+                </a:solidFill>
+                <a:latin typeface="Calibri" pitchFamily="34" charset="0"/>
+                <a:ea typeface="Calibri" pitchFamily="34" charset="-122"/>
+                <a:cs typeface="Calibri" pitchFamily="34" charset="-120"/>
+              </a:rPr>
+              <a:t>THE TAKEAWAY   </a:t>
+            </a:r>
+            <a:pPr indent="0" marL="0">
+              <a:buNone/>
+            </a:pPr>
+            <a:r>
+              <a:rPr lang="en-US" sz="1300" b="1" dirty="0">
+                <a:solidFill>
+                  <a:srgbClr val="0A1F33"/>
+                </a:solidFill>
+                <a:latin typeface="Calibri" pitchFamily="34" charset="0"/>
+                <a:ea typeface="Calibri" pitchFamily="34" charset="-122"/>
+                <a:cs typeface="Calibri" pitchFamily="34" charset="-120"/>
+              </a:rPr>
+              <a:t>Capacity is not the constraint. One small peer has rated debt a hundred times ACER's yearly target over its life; the binding constraint is winning mandates, so execution and the licence decide the pace, not demand.</a:t>
+            </a:r>
+            <a:endParaRPr lang="en-US" sz="1000" dirty="0"/>
+          </a:p>
+        </p:txBody>
+      </p:sp>
+      <p:sp>
+        <p:nvSpPr>
+          <p:cNvPr id="28" name="Shape 26"/>
+          <p:cNvSpPr/>
+          <p:nvPr/>
+        </p:nvSpPr>
+        <p:spPr>
+          <a:xfrm>
+            <a:off x="640080" y="6437376"/>
+            <a:ext cx="10911535" cy="0"/>
+          </a:xfrm>
+          <a:prstGeom prst="line">
+            <a:avLst/>
+          </a:prstGeom>
+          <a:noFill/>
+          <a:ln w="12700">
+            <a:solidFill>
+              <a:srgbClr val="E6E9EE"/>
+            </a:solidFill>
+            <a:prstDash val="solid"/>
+          </a:ln>
+        </p:spPr>
+      </p:sp>
+      <p:sp>
+        <p:nvSpPr>
+          <p:cNvPr id="29" name="Text 27"/>
+          <p:cNvSpPr/>
+          <p:nvPr/>
+        </p:nvSpPr>
+        <p:spPr>
+          <a:xfrm>
+            <a:off x="640080" y="6483096"/>
+            <a:ext cx="9509760" cy="292608"/>
+          </a:xfrm>
+          <a:prstGeom prst="rect">
+            <a:avLst/>
+          </a:prstGeom>
+          <a:noFill/>
+          <a:ln/>
+        </p:spPr>
+        <p:txBody>
+          <a:bodyPr wrap="square" rtlCol="0" anchor="t"/>
+          <a:lstStyle/>
+          <a:p>
+            <a:pPr indent="0" marL="0">
+              <a:buNone/>
+            </a:pPr>
+            <a:r>
+              <a:rPr lang="en-US" sz="850" dirty="0">
+                <a:solidFill>
+                  <a:srgbClr val="9AA7B4"/>
+                </a:solidFill>
+                <a:latin typeface="Calibri" pitchFamily="34" charset="0"/>
+                <a:ea typeface="Calibri" pitchFamily="34" charset="-122"/>
+                <a:cs typeface="Calibri" pitchFamily="34" charset="-120"/>
+              </a:rPr>
+              <a:t>Source: India bank credit ~Rs 70 lakh cr, RBI via Business Standard [11]; bond issuance ~Rs 10 lakh cr [13]; Brickwork lifetime rated debt, brickworkratings.com [9]; CRISIL ~19,500 issuers [12]. Peer figures cumulative, used for scale.</a:t>
             </a:r>
             <a:endParaRPr lang="en-US" sz="850" dirty="0"/>
           </a:p>
@@ -12008,7 +11845,7 @@
       </p:sp>
       <p:sp>
         <p:nvSpPr>
-          <p:cNvPr id="23" name="Text 20"/>
+          <p:cNvPr id="30" name="Text 28"/>
           <p:cNvSpPr/>
           <p:nvPr/>
         </p:nvSpPr>

</xml_diff>